<commit_message>
feat: full architecture slide with 4 layers (app, model, scoring, infra)
Slide 3 now shows the complete technical stack:
- Application layer: Clay → Claude 4.6 → BrainReach UI → Send via Clay + Convex
- TRIBE v2 Model: LLaMA 3.2 + Wav2Vec-BERT + V-JEPA2 → Brain encoder → 20,484 vertices
- Scoring: Destrieux Atlas → 5 ROI scores (Attention, Curiosity, Trust, Motivation, Resistance) → Kahneman peak-end
- Infrastructure: CoreWeave → NVIDIA B200 (180GB) → Northflank → FastAPI

Co-Authored-By: Claude Opus 4.6 (1M context) <noreply@anthropic.com>
</commit_message>
<xml_diff>
--- a/BrainReach_Pitch.pptx
+++ b/BrainReach_Pitch.pptx
@@ -4328,22 +4328,22 @@
         </p:nvSpPr>
         <p:spPr>
           <a:xfrm>
-            <a:off x="0" y="457200"/>
-            <a:ext cx="12191695" cy="914400"/>
-          </a:xfrm>
-          <a:prstGeom prst="rect">
-            <a:avLst/>
-          </a:prstGeom>
-          <a:noFill/>
-        </p:spPr>
-        <p:txBody>
-          <a:bodyPr wrap="square">
-            <a:spAutoFit/>
-          </a:bodyPr>
-          <a:lstStyle/>
-          <a:p>
-            <a:pPr algn="ctr">
-              <a:defRPr sz="1800" b="0">
+            <a:off x="0" y="274320"/>
+            <a:ext cx="12191695" cy="548640"/>
+          </a:xfrm>
+          <a:prstGeom prst="rect">
+            <a:avLst/>
+          </a:prstGeom>
+          <a:noFill/>
+        </p:spPr>
+        <p:txBody>
+          <a:bodyPr wrap="square">
+            <a:spAutoFit/>
+          </a:bodyPr>
+          <a:lstStyle/>
+          <a:p>
+            <a:pPr algn="ctr">
+              <a:defRPr sz="1600" b="0">
                 <a:solidFill>
                   <a:srgbClr val="93AED2"/>
                 </a:solidFill>
@@ -4351,7 +4351,7 @@
               </a:defRPr>
             </a:pPr>
             <a:r>
-              <a:t>How It Works</a:t>
+              <a:t>Architecture</a:t>
             </a:r>
           </a:p>
         </p:txBody>
@@ -4364,22 +4364,22 @@
         </p:nvSpPr>
         <p:spPr>
           <a:xfrm>
-            <a:off x="0" y="914400"/>
-            <a:ext cx="12191695" cy="914400"/>
-          </a:xfrm>
-          <a:prstGeom prst="rect">
-            <a:avLst/>
-          </a:prstGeom>
-          <a:noFill/>
-        </p:spPr>
-        <p:txBody>
-          <a:bodyPr wrap="square">
-            <a:spAutoFit/>
-          </a:bodyPr>
-          <a:lstStyle/>
-          <a:p>
-            <a:pPr algn="ctr">
-              <a:defRPr sz="3600" b="1">
+            <a:off x="0" y="640080"/>
+            <a:ext cx="12191695" cy="640080"/>
+          </a:xfrm>
+          <a:prstGeom prst="rect">
+            <a:avLst/>
+          </a:prstGeom>
+          <a:noFill/>
+        </p:spPr>
+        <p:txBody>
+          <a:bodyPr wrap="square">
+            <a:spAutoFit/>
+          </a:bodyPr>
+          <a:lstStyle/>
+          <a:p>
+            <a:pPr algn="ctr">
+              <a:defRPr sz="3200" b="1">
                 <a:solidFill>
                   <a:srgbClr val="FFFFFF"/>
                 </a:solidFill>
@@ -4387,21 +4387,57 @@
               </a:defRPr>
             </a:pPr>
             <a:r>
-              <a:t>BrainReach Architecture</a:t>
-            </a:r>
-          </a:p>
-        </p:txBody>
-      </p:sp>
-      <p:sp>
-        <p:nvSpPr>
-          <p:cNvPr id="4" name="Rounded Rectangle 3"/>
+              <a:t>BrainReach — Full Stack</a:t>
+            </a:r>
+          </a:p>
+        </p:txBody>
+      </p:sp>
+      <p:sp>
+        <p:nvSpPr>
+          <p:cNvPr id="4" name="TextBox 3"/>
+          <p:cNvSpPr txBox="1"/>
+          <p:nvPr/>
+        </p:nvSpPr>
+        <p:spPr>
+          <a:xfrm>
+            <a:off x="365760" y="1371600"/>
+            <a:ext cx="1828800" cy="365760"/>
+          </a:xfrm>
+          <a:prstGeom prst="rect">
+            <a:avLst/>
+          </a:prstGeom>
+          <a:noFill/>
+        </p:spPr>
+        <p:txBody>
+          <a:bodyPr wrap="square">
+            <a:spAutoFit/>
+          </a:bodyPr>
+          <a:lstStyle/>
+          <a:p>
+            <a:pPr algn="l">
+              <a:defRPr sz="1000" b="1">
+                <a:solidFill>
+                  <a:srgbClr val="93AED2"/>
+                </a:solidFill>
+                <a:latin typeface="Arial"/>
+              </a:defRPr>
+            </a:pPr>
+            <a:r>
+              <a:t>APPLICATION</a:t>
+            </a:r>
+          </a:p>
+        </p:txBody>
+      </p:sp>
+      <p:sp>
+        <p:nvSpPr>
+          <p:cNvPr id="5" name="Rounded Rectangle 4"/>
           <p:cNvSpPr/>
           <p:nvPr/>
         </p:nvSpPr>
         <p:spPr>
           <a:xfrm>
-            <a:off x="472287" y="2560320"/>
-            <a:ext cx="2194560" cy="1280160"/>
+            <a:off x="731520" y="1737360"/>
+            <a:ext cx="1828800" cy="822960"/>
           </a:xfrm>
           <a:prstGeom prst="roundRect">
             <a:avLst>
@@ -4439,28 +4475,28 @@
       </p:sp>
       <p:sp>
         <p:nvSpPr>
-          <p:cNvPr id="5" name="TextBox 4"/>
-          <p:cNvSpPr txBox="1"/>
-          <p:nvPr/>
-        </p:nvSpPr>
-        <p:spPr>
-          <a:xfrm>
-            <a:off x="472287" y="2788920"/>
-            <a:ext cx="2194560" cy="548640"/>
-          </a:xfrm>
-          <a:prstGeom prst="rect">
-            <a:avLst/>
-          </a:prstGeom>
-          <a:noFill/>
-        </p:spPr>
-        <p:txBody>
-          <a:bodyPr wrap="square">
-            <a:spAutoFit/>
-          </a:bodyPr>
-          <a:lstStyle/>
-          <a:p>
-            <a:pPr algn="ctr">
-              <a:defRPr sz="2000" b="1">
+          <p:cNvPr id="6" name="TextBox 5"/>
+          <p:cNvSpPr txBox="1"/>
+          <p:nvPr/>
+        </p:nvSpPr>
+        <p:spPr>
+          <a:xfrm>
+            <a:off x="731520" y="1860804"/>
+            <a:ext cx="1828800" cy="370332"/>
+          </a:xfrm>
+          <a:prstGeom prst="rect">
+            <a:avLst/>
+          </a:prstGeom>
+          <a:noFill/>
+        </p:spPr>
+        <p:txBody>
+          <a:bodyPr wrap="square">
+            <a:spAutoFit/>
+          </a:bodyPr>
+          <a:lstStyle/>
+          <a:p>
+            <a:pPr algn="ctr">
+              <a:defRPr sz="1300" b="1">
                 <a:solidFill>
                   <a:srgbClr val="FFFFFF"/>
                 </a:solidFill>
@@ -4475,28 +4511,28 @@
       </p:sp>
       <p:sp>
         <p:nvSpPr>
-          <p:cNvPr id="6" name="TextBox 5"/>
-          <p:cNvSpPr txBox="1"/>
-          <p:nvPr/>
-        </p:nvSpPr>
-        <p:spPr>
-          <a:xfrm>
-            <a:off x="472287" y="3246120"/>
-            <a:ext cx="2194560" cy="365760"/>
-          </a:xfrm>
-          <a:prstGeom prst="rect">
-            <a:avLst/>
-          </a:prstGeom>
-          <a:noFill/>
-        </p:spPr>
-        <p:txBody>
-          <a:bodyPr wrap="square">
-            <a:spAutoFit/>
-          </a:bodyPr>
-          <a:lstStyle/>
-          <a:p>
-            <a:pPr algn="ctr">
-              <a:defRPr sz="1300" b="0">
+          <p:cNvPr id="7" name="TextBox 6"/>
+          <p:cNvSpPr txBox="1"/>
+          <p:nvPr/>
+        </p:nvSpPr>
+        <p:spPr>
+          <a:xfrm>
+            <a:off x="731520" y="2148840"/>
+            <a:ext cx="1828800" cy="329184"/>
+          </a:xfrm>
+          <a:prstGeom prst="rect">
+            <a:avLst/>
+          </a:prstGeom>
+          <a:noFill/>
+        </p:spPr>
+        <p:txBody>
+          <a:bodyPr wrap="square">
+            <a:spAutoFit/>
+          </a:bodyPr>
+          <a:lstStyle/>
+          <a:p>
+            <a:pPr algn="ctr">
+              <a:defRPr sz="900" b="0">
                 <a:solidFill>
                   <a:srgbClr val="FFFFFF"/>
                 </a:solidFill>
@@ -4504,35 +4540,35 @@
               </a:defRPr>
             </a:pPr>
             <a:r>
-              <a:t>Leads + OCEAN</a:t>
-            </a:r>
-          </a:p>
-        </p:txBody>
-      </p:sp>
-      <p:sp>
-        <p:nvSpPr>
-          <p:cNvPr id="7" name="TextBox 6"/>
-          <p:cNvSpPr txBox="1"/>
-          <p:nvPr/>
-        </p:nvSpPr>
-        <p:spPr>
-          <a:xfrm>
-            <a:off x="2712567" y="2834639"/>
-            <a:ext cx="548640" cy="731520"/>
-          </a:xfrm>
-          <a:prstGeom prst="rect">
-            <a:avLst/>
-          </a:prstGeom>
-          <a:noFill/>
-        </p:spPr>
-        <p:txBody>
-          <a:bodyPr wrap="square">
-            <a:spAutoFit/>
-          </a:bodyPr>
-          <a:lstStyle/>
-          <a:p>
-            <a:pPr algn="ctr">
-              <a:defRPr sz="3200" b="0">
+              <a:t>Leads + OCEAN profiles</a:t>
+            </a:r>
+          </a:p>
+        </p:txBody>
+      </p:sp>
+      <p:sp>
+        <p:nvSpPr>
+          <p:cNvPr id="8" name="TextBox 7"/>
+          <p:cNvSpPr txBox="1"/>
+          <p:nvPr/>
+        </p:nvSpPr>
+        <p:spPr>
+          <a:xfrm>
+            <a:off x="2651760" y="1965960"/>
+            <a:ext cx="457200" cy="365760"/>
+          </a:xfrm>
+          <a:prstGeom prst="rect">
+            <a:avLst/>
+          </a:prstGeom>
+          <a:noFill/>
+        </p:spPr>
+        <p:txBody>
+          <a:bodyPr wrap="square">
+            <a:spAutoFit/>
+          </a:bodyPr>
+          <a:lstStyle/>
+          <a:p>
+            <a:pPr algn="ctr">
+              <a:defRPr sz="2200" b="0">
                 <a:solidFill>
                   <a:srgbClr val="607DB8"/>
                 </a:solidFill>
@@ -4547,14 +4583,14 @@
       </p:sp>
       <p:sp>
         <p:nvSpPr>
-          <p:cNvPr id="8" name="Rounded Rectangle 7"/>
+          <p:cNvPr id="9" name="Rounded Rectangle 8"/>
           <p:cNvSpPr/>
           <p:nvPr/>
         </p:nvSpPr>
         <p:spPr>
           <a:xfrm>
-            <a:off x="3489807" y="2560320"/>
-            <a:ext cx="2194560" cy="1280160"/>
+            <a:off x="3108960" y="1737360"/>
+            <a:ext cx="2011680" cy="822960"/>
           </a:xfrm>
           <a:prstGeom prst="roundRect">
             <a:avLst>
@@ -4592,28 +4628,28 @@
       </p:sp>
       <p:sp>
         <p:nvSpPr>
-          <p:cNvPr id="9" name="TextBox 8"/>
-          <p:cNvSpPr txBox="1"/>
-          <p:nvPr/>
-        </p:nvSpPr>
-        <p:spPr>
-          <a:xfrm>
-            <a:off x="3489807" y="2788920"/>
-            <a:ext cx="2194560" cy="548640"/>
-          </a:xfrm>
-          <a:prstGeom prst="rect">
-            <a:avLst/>
-          </a:prstGeom>
-          <a:noFill/>
-        </p:spPr>
-        <p:txBody>
-          <a:bodyPr wrap="square">
-            <a:spAutoFit/>
-          </a:bodyPr>
-          <a:lstStyle/>
-          <a:p>
-            <a:pPr algn="ctr">
-              <a:defRPr sz="2000" b="1">
+          <p:cNvPr id="10" name="TextBox 9"/>
+          <p:cNvSpPr txBox="1"/>
+          <p:nvPr/>
+        </p:nvSpPr>
+        <p:spPr>
+          <a:xfrm>
+            <a:off x="3108960" y="1860804"/>
+            <a:ext cx="2011680" cy="370332"/>
+          </a:xfrm>
+          <a:prstGeom prst="rect">
+            <a:avLst/>
+          </a:prstGeom>
+          <a:noFill/>
+        </p:spPr>
+        <p:txBody>
+          <a:bodyPr wrap="square">
+            <a:spAutoFit/>
+          </a:bodyPr>
+          <a:lstStyle/>
+          <a:p>
+            <a:pPr algn="ctr">
+              <a:defRPr sz="1300" b="1">
                 <a:solidFill>
                   <a:srgbClr val="FFFFFF"/>
                 </a:solidFill>
@@ -4621,35 +4657,35 @@
               </a:defRPr>
             </a:pPr>
             <a:r>
-              <a:t>Claude 4.6</a:t>
-            </a:r>
-          </a:p>
-        </p:txBody>
-      </p:sp>
-      <p:sp>
-        <p:nvSpPr>
-          <p:cNvPr id="10" name="TextBox 9"/>
-          <p:cNvSpPr txBox="1"/>
-          <p:nvPr/>
-        </p:nvSpPr>
-        <p:spPr>
-          <a:xfrm>
-            <a:off x="3489807" y="3246120"/>
-            <a:ext cx="2194560" cy="365760"/>
-          </a:xfrm>
-          <a:prstGeom prst="rect">
-            <a:avLst/>
-          </a:prstGeom>
-          <a:noFill/>
-        </p:spPr>
-        <p:txBody>
-          <a:bodyPr wrap="square">
-            <a:spAutoFit/>
-          </a:bodyPr>
-          <a:lstStyle/>
-          <a:p>
-            <a:pPr algn="ctr">
-              <a:defRPr sz="1300" b="0">
+              <a:t>Claude Sonnet 4.6</a:t>
+            </a:r>
+          </a:p>
+        </p:txBody>
+      </p:sp>
+      <p:sp>
+        <p:nvSpPr>
+          <p:cNvPr id="11" name="TextBox 10"/>
+          <p:cNvSpPr txBox="1"/>
+          <p:nvPr/>
+        </p:nvSpPr>
+        <p:spPr>
+          <a:xfrm>
+            <a:off x="3108960" y="2148840"/>
+            <a:ext cx="2011680" cy="329184"/>
+          </a:xfrm>
+          <a:prstGeom prst="rect">
+            <a:avLst/>
+          </a:prstGeom>
+          <a:noFill/>
+        </p:spPr>
+        <p:txBody>
+          <a:bodyPr wrap="square">
+            <a:spAutoFit/>
+          </a:bodyPr>
+          <a:lstStyle/>
+          <a:p>
+            <a:pPr algn="ctr">
+              <a:defRPr sz="900" b="0">
                 <a:solidFill>
                   <a:srgbClr val="FFFFFF"/>
                 </a:solidFill>
@@ -4657,35 +4693,35 @@
               </a:defRPr>
             </a:pPr>
             <a:r>
-              <a:t>Variants</a:t>
-            </a:r>
-          </a:p>
-        </p:txBody>
-      </p:sp>
-      <p:sp>
-        <p:nvSpPr>
-          <p:cNvPr id="11" name="TextBox 10"/>
-          <p:cNvSpPr txBox="1"/>
-          <p:nvPr/>
-        </p:nvSpPr>
-        <p:spPr>
-          <a:xfrm>
-            <a:off x="5730087" y="2834639"/>
-            <a:ext cx="548640" cy="731520"/>
-          </a:xfrm>
-          <a:prstGeom prst="rect">
-            <a:avLst/>
-          </a:prstGeom>
-          <a:noFill/>
-        </p:spPr>
-        <p:txBody>
-          <a:bodyPr wrap="square">
-            <a:spAutoFit/>
-          </a:bodyPr>
-          <a:lstStyle/>
-          <a:p>
-            <a:pPr algn="ctr">
-              <a:defRPr sz="3200" b="0">
+              <a:t>Generate + optimize</a:t>
+            </a:r>
+          </a:p>
+        </p:txBody>
+      </p:sp>
+      <p:sp>
+        <p:nvSpPr>
+          <p:cNvPr id="12" name="TextBox 11"/>
+          <p:cNvSpPr txBox="1"/>
+          <p:nvPr/>
+        </p:nvSpPr>
+        <p:spPr>
+          <a:xfrm>
+            <a:off x="5212080" y="1965960"/>
+            <a:ext cx="457200" cy="365760"/>
+          </a:xfrm>
+          <a:prstGeom prst="rect">
+            <a:avLst/>
+          </a:prstGeom>
+          <a:noFill/>
+        </p:spPr>
+        <p:txBody>
+          <a:bodyPr wrap="square">
+            <a:spAutoFit/>
+          </a:bodyPr>
+          <a:lstStyle/>
+          <a:p>
+            <a:pPr algn="ctr">
+              <a:defRPr sz="2200" b="0">
                 <a:solidFill>
                   <a:srgbClr val="607DB8"/>
                 </a:solidFill>
@@ -4700,14 +4736,794 @@
       </p:sp>
       <p:sp>
         <p:nvSpPr>
-          <p:cNvPr id="12" name="Rounded Rectangle 11"/>
+          <p:cNvPr id="13" name="Rounded Rectangle 12"/>
           <p:cNvSpPr/>
           <p:nvPr/>
         </p:nvSpPr>
         <p:spPr>
           <a:xfrm>
-            <a:off x="6507327" y="2560320"/>
-            <a:ext cx="2194560" cy="1280160"/>
+            <a:off x="5669280" y="1737360"/>
+            <a:ext cx="2377440" cy="822960"/>
+          </a:xfrm>
+          <a:prstGeom prst="roundRect">
+            <a:avLst>
+              <a:gd name="adj" fmla="val 10000"/>
+            </a:avLst>
+          </a:prstGeom>
+          <a:solidFill>
+            <a:srgbClr val="10B981"/>
+          </a:solidFill>
+          <a:ln>
+            <a:noFill/>
+          </a:ln>
+        </p:spPr>
+        <p:style>
+          <a:lnRef idx="1">
+            <a:schemeClr val="accent1"/>
+          </a:lnRef>
+          <a:fillRef idx="3">
+            <a:schemeClr val="accent1"/>
+          </a:fillRef>
+          <a:effectRef idx="2">
+            <a:schemeClr val="accent1"/>
+          </a:effectRef>
+          <a:fontRef idx="minor">
+            <a:schemeClr val="lt1"/>
+          </a:fontRef>
+        </p:style>
+        <p:txBody>
+          <a:bodyPr rtlCol="0" anchor="ctr"/>
+          <a:lstStyle/>
+          <a:p>
+            <a:pPr algn="ctr"/>
+          </a:p>
+        </p:txBody>
+      </p:sp>
+      <p:sp>
+        <p:nvSpPr>
+          <p:cNvPr id="14" name="TextBox 13"/>
+          <p:cNvSpPr txBox="1"/>
+          <p:nvPr/>
+        </p:nvSpPr>
+        <p:spPr>
+          <a:xfrm>
+            <a:off x="5669280" y="1860804"/>
+            <a:ext cx="2377440" cy="370332"/>
+          </a:xfrm>
+          <a:prstGeom prst="rect">
+            <a:avLst/>
+          </a:prstGeom>
+          <a:noFill/>
+        </p:spPr>
+        <p:txBody>
+          <a:bodyPr wrap="square">
+            <a:spAutoFit/>
+          </a:bodyPr>
+          <a:lstStyle/>
+          <a:p>
+            <a:pPr algn="ctr">
+              <a:defRPr sz="1300" b="1">
+                <a:solidFill>
+                  <a:srgbClr val="FFFFFF"/>
+                </a:solidFill>
+                <a:latin typeface="Arial"/>
+              </a:defRPr>
+            </a:pPr>
+            <a:r>
+              <a:t>BrainReach UI</a:t>
+            </a:r>
+          </a:p>
+        </p:txBody>
+      </p:sp>
+      <p:sp>
+        <p:nvSpPr>
+          <p:cNvPr id="15" name="TextBox 14"/>
+          <p:cNvSpPr txBox="1"/>
+          <p:nvPr/>
+        </p:nvSpPr>
+        <p:spPr>
+          <a:xfrm>
+            <a:off x="5669280" y="2148840"/>
+            <a:ext cx="2377440" cy="329184"/>
+          </a:xfrm>
+          <a:prstGeom prst="rect">
+            <a:avLst/>
+          </a:prstGeom>
+          <a:noFill/>
+        </p:spPr>
+        <p:txBody>
+          <a:bodyPr wrap="square">
+            <a:spAutoFit/>
+          </a:bodyPr>
+          <a:lstStyle/>
+          <a:p>
+            <a:pPr algn="ctr">
+              <a:defRPr sz="900" b="0">
+                <a:solidFill>
+                  <a:srgbClr val="FFFFFF"/>
+                </a:solidFill>
+                <a:latin typeface="Arial"/>
+              </a:defRPr>
+            </a:pPr>
+            <a:r>
+              <a:t>Tree · Brain 3D · Scores</a:t>
+            </a:r>
+          </a:p>
+        </p:txBody>
+      </p:sp>
+      <p:sp>
+        <p:nvSpPr>
+          <p:cNvPr id="16" name="TextBox 15"/>
+          <p:cNvSpPr txBox="1"/>
+          <p:nvPr/>
+        </p:nvSpPr>
+        <p:spPr>
+          <a:xfrm>
+            <a:off x="8138160" y="1965960"/>
+            <a:ext cx="457200" cy="365760"/>
+          </a:xfrm>
+          <a:prstGeom prst="rect">
+            <a:avLst/>
+          </a:prstGeom>
+          <a:noFill/>
+        </p:spPr>
+        <p:txBody>
+          <a:bodyPr wrap="square">
+            <a:spAutoFit/>
+          </a:bodyPr>
+          <a:lstStyle/>
+          <a:p>
+            <a:pPr algn="ctr">
+              <a:defRPr sz="2200" b="0">
+                <a:solidFill>
+                  <a:srgbClr val="607DB8"/>
+                </a:solidFill>
+                <a:latin typeface="Arial"/>
+              </a:defRPr>
+            </a:pPr>
+            <a:r>
+              <a:t>→</a:t>
+            </a:r>
+          </a:p>
+        </p:txBody>
+      </p:sp>
+      <p:sp>
+        <p:nvSpPr>
+          <p:cNvPr id="17" name="Rounded Rectangle 16"/>
+          <p:cNvSpPr/>
+          <p:nvPr/>
+        </p:nvSpPr>
+        <p:spPr>
+          <a:xfrm>
+            <a:off x="8595360" y="1737360"/>
+            <a:ext cx="1828800" cy="822960"/>
+          </a:xfrm>
+          <a:prstGeom prst="roundRect">
+            <a:avLst>
+              <a:gd name="adj" fmla="val 10000"/>
+            </a:avLst>
+          </a:prstGeom>
+          <a:solidFill>
+            <a:srgbClr val="F97316"/>
+          </a:solidFill>
+          <a:ln>
+            <a:noFill/>
+          </a:ln>
+        </p:spPr>
+        <p:style>
+          <a:lnRef idx="1">
+            <a:schemeClr val="accent1"/>
+          </a:lnRef>
+          <a:fillRef idx="3">
+            <a:schemeClr val="accent1"/>
+          </a:fillRef>
+          <a:effectRef idx="2">
+            <a:schemeClr val="accent1"/>
+          </a:effectRef>
+          <a:fontRef idx="minor">
+            <a:schemeClr val="lt1"/>
+          </a:fontRef>
+        </p:style>
+        <p:txBody>
+          <a:bodyPr rtlCol="0" anchor="ctr"/>
+          <a:lstStyle/>
+          <a:p>
+            <a:pPr algn="ctr"/>
+          </a:p>
+        </p:txBody>
+      </p:sp>
+      <p:sp>
+        <p:nvSpPr>
+          <p:cNvPr id="18" name="TextBox 17"/>
+          <p:cNvSpPr txBox="1"/>
+          <p:nvPr/>
+        </p:nvSpPr>
+        <p:spPr>
+          <a:xfrm>
+            <a:off x="8595360" y="1860804"/>
+            <a:ext cx="1828800" cy="370332"/>
+          </a:xfrm>
+          <a:prstGeom prst="rect">
+            <a:avLst/>
+          </a:prstGeom>
+          <a:noFill/>
+        </p:spPr>
+        <p:txBody>
+          <a:bodyPr wrap="square">
+            <a:spAutoFit/>
+          </a:bodyPr>
+          <a:lstStyle/>
+          <a:p>
+            <a:pPr algn="ctr">
+              <a:defRPr sz="1300" b="1">
+                <a:solidFill>
+                  <a:srgbClr val="FFFFFF"/>
+                </a:solidFill>
+                <a:latin typeface="Arial"/>
+              </a:defRPr>
+            </a:pPr>
+            <a:r>
+              <a:t>Send via Clay</a:t>
+            </a:r>
+          </a:p>
+        </p:txBody>
+      </p:sp>
+      <p:sp>
+        <p:nvSpPr>
+          <p:cNvPr id="19" name="TextBox 18"/>
+          <p:cNvSpPr txBox="1"/>
+          <p:nvPr/>
+        </p:nvSpPr>
+        <p:spPr>
+          <a:xfrm>
+            <a:off x="8595360" y="2148840"/>
+            <a:ext cx="1828800" cy="329184"/>
+          </a:xfrm>
+          <a:prstGeom prst="rect">
+            <a:avLst/>
+          </a:prstGeom>
+          <a:noFill/>
+        </p:spPr>
+        <p:txBody>
+          <a:bodyPr wrap="square">
+            <a:spAutoFit/>
+          </a:bodyPr>
+          <a:lstStyle/>
+          <a:p>
+            <a:pPr algn="ctr">
+              <a:defRPr sz="900" b="0">
+                <a:solidFill>
+                  <a:srgbClr val="FFFFFF"/>
+                </a:solidFill>
+                <a:latin typeface="Arial"/>
+              </a:defRPr>
+            </a:pPr>
+            <a:r>
+              <a:t>Outreach delivery</a:t>
+            </a:r>
+          </a:p>
+        </p:txBody>
+      </p:sp>
+      <p:sp>
+        <p:nvSpPr>
+          <p:cNvPr id="20" name="Rounded Rectangle 19"/>
+          <p:cNvSpPr/>
+          <p:nvPr/>
+        </p:nvSpPr>
+        <p:spPr>
+          <a:xfrm>
+            <a:off x="10698480" y="1737360"/>
+            <a:ext cx="1097280" cy="822960"/>
+          </a:xfrm>
+          <a:prstGeom prst="roundRect">
+            <a:avLst>
+              <a:gd name="adj" fmla="val 12000"/>
+            </a:avLst>
+          </a:prstGeom>
+          <a:solidFill>
+            <a:srgbClr val="1B336B"/>
+          </a:solidFill>
+          <a:ln w="25400">
+            <a:solidFill>
+              <a:srgbClr val="22D3EE"/>
+            </a:solidFill>
+          </a:ln>
+        </p:spPr>
+        <p:style>
+          <a:lnRef idx="1">
+            <a:schemeClr val="accent1"/>
+          </a:lnRef>
+          <a:fillRef idx="3">
+            <a:schemeClr val="accent1"/>
+          </a:fillRef>
+          <a:effectRef idx="2">
+            <a:schemeClr val="accent1"/>
+          </a:effectRef>
+          <a:fontRef idx="minor">
+            <a:schemeClr val="lt1"/>
+          </a:fontRef>
+        </p:style>
+        <p:txBody>
+          <a:bodyPr rtlCol="0" anchor="ctr"/>
+          <a:lstStyle/>
+          <a:p>
+            <a:pPr algn="ctr"/>
+          </a:p>
+        </p:txBody>
+      </p:sp>
+      <p:sp>
+        <p:nvSpPr>
+          <p:cNvPr id="21" name="TextBox 20"/>
+          <p:cNvSpPr txBox="1"/>
+          <p:nvPr/>
+        </p:nvSpPr>
+        <p:spPr>
+          <a:xfrm>
+            <a:off x="10698480" y="1860804"/>
+            <a:ext cx="1097280" cy="576072"/>
+          </a:xfrm>
+          <a:prstGeom prst="rect">
+            <a:avLst/>
+          </a:prstGeom>
+          <a:noFill/>
+        </p:spPr>
+        <p:txBody>
+          <a:bodyPr wrap="square">
+            <a:spAutoFit/>
+          </a:bodyPr>
+          <a:lstStyle/>
+          <a:p>
+            <a:pPr algn="ctr">
+              <a:defRPr sz="1000" b="1">
+                <a:solidFill>
+                  <a:srgbClr val="FFFFFF"/>
+                </a:solidFill>
+                <a:latin typeface="Arial"/>
+              </a:defRPr>
+            </a:pPr>
+            <a:r>
+              <a:t>Convex</a:t>
+            </a:r>
+            <a:br/>
+            <a:r>
+              <a:t>Realtime DB</a:t>
+            </a:r>
+          </a:p>
+        </p:txBody>
+      </p:sp>
+      <p:sp>
+        <p:nvSpPr>
+          <p:cNvPr id="22" name="TextBox 21"/>
+          <p:cNvSpPr txBox="1"/>
+          <p:nvPr/>
+        </p:nvSpPr>
+        <p:spPr>
+          <a:xfrm>
+            <a:off x="365760" y="2834640"/>
+            <a:ext cx="1828800" cy="365760"/>
+          </a:xfrm>
+          <a:prstGeom prst="rect">
+            <a:avLst/>
+          </a:prstGeom>
+          <a:noFill/>
+        </p:spPr>
+        <p:txBody>
+          <a:bodyPr wrap="square">
+            <a:spAutoFit/>
+          </a:bodyPr>
+          <a:lstStyle/>
+          <a:p>
+            <a:pPr algn="l">
+              <a:defRPr sz="1000" b="1">
+                <a:solidFill>
+                  <a:srgbClr val="93AED2"/>
+                </a:solidFill>
+                <a:latin typeface="Arial"/>
+              </a:defRPr>
+            </a:pPr>
+            <a:r>
+              <a:t>TRIBE v2 MODEL</a:t>
+            </a:r>
+          </a:p>
+        </p:txBody>
+      </p:sp>
+      <p:sp>
+        <p:nvSpPr>
+          <p:cNvPr id="23" name="Rounded Rectangle 22"/>
+          <p:cNvSpPr/>
+          <p:nvPr/>
+        </p:nvSpPr>
+        <p:spPr>
+          <a:xfrm>
+            <a:off x="731520" y="3200400"/>
+            <a:ext cx="1828800" cy="777240"/>
+          </a:xfrm>
+          <a:prstGeom prst="roundRect">
+            <a:avLst>
+              <a:gd name="adj" fmla="val 10000"/>
+            </a:avLst>
+          </a:prstGeom>
+          <a:solidFill>
+            <a:srgbClr val="7C3AED"/>
+          </a:solidFill>
+          <a:ln>
+            <a:noFill/>
+          </a:ln>
+        </p:spPr>
+        <p:style>
+          <a:lnRef idx="1">
+            <a:schemeClr val="accent1"/>
+          </a:lnRef>
+          <a:fillRef idx="3">
+            <a:schemeClr val="accent1"/>
+          </a:fillRef>
+          <a:effectRef idx="2">
+            <a:schemeClr val="accent1"/>
+          </a:effectRef>
+          <a:fontRef idx="minor">
+            <a:schemeClr val="lt1"/>
+          </a:fontRef>
+        </p:style>
+        <p:txBody>
+          <a:bodyPr rtlCol="0" anchor="ctr"/>
+          <a:lstStyle/>
+          <a:p>
+            <a:pPr algn="ctr"/>
+          </a:p>
+        </p:txBody>
+      </p:sp>
+      <p:sp>
+        <p:nvSpPr>
+          <p:cNvPr id="24" name="TextBox 23"/>
+          <p:cNvSpPr txBox="1"/>
+          <p:nvPr/>
+        </p:nvSpPr>
+        <p:spPr>
+          <a:xfrm>
+            <a:off x="731520" y="3316986"/>
+            <a:ext cx="1828800" cy="349758"/>
+          </a:xfrm>
+          <a:prstGeom prst="rect">
+            <a:avLst/>
+          </a:prstGeom>
+          <a:noFill/>
+        </p:spPr>
+        <p:txBody>
+          <a:bodyPr wrap="square">
+            <a:spAutoFit/>
+          </a:bodyPr>
+          <a:lstStyle/>
+          <a:p>
+            <a:pPr algn="ctr">
+              <a:defRPr sz="1200" b="1">
+                <a:solidFill>
+                  <a:srgbClr val="FFFFFF"/>
+                </a:solidFill>
+                <a:latin typeface="Arial"/>
+              </a:defRPr>
+            </a:pPr>
+            <a:r>
+              <a:t>LLaMA 3.2</a:t>
+            </a:r>
+          </a:p>
+        </p:txBody>
+      </p:sp>
+      <p:sp>
+        <p:nvSpPr>
+          <p:cNvPr id="25" name="TextBox 24"/>
+          <p:cNvSpPr txBox="1"/>
+          <p:nvPr/>
+        </p:nvSpPr>
+        <p:spPr>
+          <a:xfrm>
+            <a:off x="731520" y="3589020"/>
+            <a:ext cx="1828800" cy="310896"/>
+          </a:xfrm>
+          <a:prstGeom prst="rect">
+            <a:avLst/>
+          </a:prstGeom>
+          <a:noFill/>
+        </p:spPr>
+        <p:txBody>
+          <a:bodyPr wrap="square">
+            <a:spAutoFit/>
+          </a:bodyPr>
+          <a:lstStyle/>
+          <a:p>
+            <a:pPr algn="ctr">
+              <a:defRPr sz="900" b="0">
+                <a:solidFill>
+                  <a:srgbClr val="FFFFFF"/>
+                </a:solidFill>
+                <a:latin typeface="Arial"/>
+              </a:defRPr>
+            </a:pPr>
+            <a:r>
+              <a:t>Text encoder</a:t>
+            </a:r>
+          </a:p>
+        </p:txBody>
+      </p:sp>
+      <p:sp>
+        <p:nvSpPr>
+          <p:cNvPr id="26" name="Rounded Rectangle 25"/>
+          <p:cNvSpPr/>
+          <p:nvPr/>
+        </p:nvSpPr>
+        <p:spPr>
+          <a:xfrm>
+            <a:off x="2743200" y="3200400"/>
+            <a:ext cx="1828800" cy="777240"/>
+          </a:xfrm>
+          <a:prstGeom prst="roundRect">
+            <a:avLst>
+              <a:gd name="adj" fmla="val 10000"/>
+            </a:avLst>
+          </a:prstGeom>
+          <a:solidFill>
+            <a:srgbClr val="7C3AED"/>
+          </a:solidFill>
+          <a:ln>
+            <a:noFill/>
+          </a:ln>
+        </p:spPr>
+        <p:style>
+          <a:lnRef idx="1">
+            <a:schemeClr val="accent1"/>
+          </a:lnRef>
+          <a:fillRef idx="3">
+            <a:schemeClr val="accent1"/>
+          </a:fillRef>
+          <a:effectRef idx="2">
+            <a:schemeClr val="accent1"/>
+          </a:effectRef>
+          <a:fontRef idx="minor">
+            <a:schemeClr val="lt1"/>
+          </a:fontRef>
+        </p:style>
+        <p:txBody>
+          <a:bodyPr rtlCol="0" anchor="ctr"/>
+          <a:lstStyle/>
+          <a:p>
+            <a:pPr algn="ctr"/>
+          </a:p>
+        </p:txBody>
+      </p:sp>
+      <p:sp>
+        <p:nvSpPr>
+          <p:cNvPr id="27" name="TextBox 26"/>
+          <p:cNvSpPr txBox="1"/>
+          <p:nvPr/>
+        </p:nvSpPr>
+        <p:spPr>
+          <a:xfrm>
+            <a:off x="2743200" y="3316986"/>
+            <a:ext cx="1828800" cy="349758"/>
+          </a:xfrm>
+          <a:prstGeom prst="rect">
+            <a:avLst/>
+          </a:prstGeom>
+          <a:noFill/>
+        </p:spPr>
+        <p:txBody>
+          <a:bodyPr wrap="square">
+            <a:spAutoFit/>
+          </a:bodyPr>
+          <a:lstStyle/>
+          <a:p>
+            <a:pPr algn="ctr">
+              <a:defRPr sz="1200" b="1">
+                <a:solidFill>
+                  <a:srgbClr val="FFFFFF"/>
+                </a:solidFill>
+                <a:latin typeface="Arial"/>
+              </a:defRPr>
+            </a:pPr>
+            <a:r>
+              <a:t>Wav2Vec-BERT</a:t>
+            </a:r>
+          </a:p>
+        </p:txBody>
+      </p:sp>
+      <p:sp>
+        <p:nvSpPr>
+          <p:cNvPr id="28" name="TextBox 27"/>
+          <p:cNvSpPr txBox="1"/>
+          <p:nvPr/>
+        </p:nvSpPr>
+        <p:spPr>
+          <a:xfrm>
+            <a:off x="2743200" y="3589020"/>
+            <a:ext cx="1828800" cy="310896"/>
+          </a:xfrm>
+          <a:prstGeom prst="rect">
+            <a:avLst/>
+          </a:prstGeom>
+          <a:noFill/>
+        </p:spPr>
+        <p:txBody>
+          <a:bodyPr wrap="square">
+            <a:spAutoFit/>
+          </a:bodyPr>
+          <a:lstStyle/>
+          <a:p>
+            <a:pPr algn="ctr">
+              <a:defRPr sz="900" b="0">
+                <a:solidFill>
+                  <a:srgbClr val="FFFFFF"/>
+                </a:solidFill>
+                <a:latin typeface="Arial"/>
+              </a:defRPr>
+            </a:pPr>
+            <a:r>
+              <a:t>Audio encoder</a:t>
+            </a:r>
+          </a:p>
+        </p:txBody>
+      </p:sp>
+      <p:sp>
+        <p:nvSpPr>
+          <p:cNvPr id="29" name="Rounded Rectangle 28"/>
+          <p:cNvSpPr/>
+          <p:nvPr/>
+        </p:nvSpPr>
+        <p:spPr>
+          <a:xfrm>
+            <a:off x="4754880" y="3200400"/>
+            <a:ext cx="1828800" cy="777240"/>
+          </a:xfrm>
+          <a:prstGeom prst="roundRect">
+            <a:avLst>
+              <a:gd name="adj" fmla="val 10000"/>
+            </a:avLst>
+          </a:prstGeom>
+          <a:solidFill>
+            <a:srgbClr val="7C3AED"/>
+          </a:solidFill>
+          <a:ln>
+            <a:noFill/>
+          </a:ln>
+        </p:spPr>
+        <p:style>
+          <a:lnRef idx="1">
+            <a:schemeClr val="accent1"/>
+          </a:lnRef>
+          <a:fillRef idx="3">
+            <a:schemeClr val="accent1"/>
+          </a:fillRef>
+          <a:effectRef idx="2">
+            <a:schemeClr val="accent1"/>
+          </a:effectRef>
+          <a:fontRef idx="minor">
+            <a:schemeClr val="lt1"/>
+          </a:fontRef>
+        </p:style>
+        <p:txBody>
+          <a:bodyPr rtlCol="0" anchor="ctr"/>
+          <a:lstStyle/>
+          <a:p>
+            <a:pPr algn="ctr"/>
+          </a:p>
+        </p:txBody>
+      </p:sp>
+      <p:sp>
+        <p:nvSpPr>
+          <p:cNvPr id="30" name="TextBox 29"/>
+          <p:cNvSpPr txBox="1"/>
+          <p:nvPr/>
+        </p:nvSpPr>
+        <p:spPr>
+          <a:xfrm>
+            <a:off x="4754880" y="3316986"/>
+            <a:ext cx="1828800" cy="349758"/>
+          </a:xfrm>
+          <a:prstGeom prst="rect">
+            <a:avLst/>
+          </a:prstGeom>
+          <a:noFill/>
+        </p:spPr>
+        <p:txBody>
+          <a:bodyPr wrap="square">
+            <a:spAutoFit/>
+          </a:bodyPr>
+          <a:lstStyle/>
+          <a:p>
+            <a:pPr algn="ctr">
+              <a:defRPr sz="1200" b="1">
+                <a:solidFill>
+                  <a:srgbClr val="FFFFFF"/>
+                </a:solidFill>
+                <a:latin typeface="Arial"/>
+              </a:defRPr>
+            </a:pPr>
+            <a:r>
+              <a:t>V-JEPA2</a:t>
+            </a:r>
+          </a:p>
+        </p:txBody>
+      </p:sp>
+      <p:sp>
+        <p:nvSpPr>
+          <p:cNvPr id="31" name="TextBox 30"/>
+          <p:cNvSpPr txBox="1"/>
+          <p:nvPr/>
+        </p:nvSpPr>
+        <p:spPr>
+          <a:xfrm>
+            <a:off x="4754880" y="3589020"/>
+            <a:ext cx="1828800" cy="310896"/>
+          </a:xfrm>
+          <a:prstGeom prst="rect">
+            <a:avLst/>
+          </a:prstGeom>
+          <a:noFill/>
+        </p:spPr>
+        <p:txBody>
+          <a:bodyPr wrap="square">
+            <a:spAutoFit/>
+          </a:bodyPr>
+          <a:lstStyle/>
+          <a:p>
+            <a:pPr algn="ctr">
+              <a:defRPr sz="900" b="0">
+                <a:solidFill>
+                  <a:srgbClr val="FFFFFF"/>
+                </a:solidFill>
+                <a:latin typeface="Arial"/>
+              </a:defRPr>
+            </a:pPr>
+            <a:r>
+              <a:t>Video encoder</a:t>
+            </a:r>
+          </a:p>
+        </p:txBody>
+      </p:sp>
+      <p:sp>
+        <p:nvSpPr>
+          <p:cNvPr id="32" name="TextBox 31"/>
+          <p:cNvSpPr txBox="1"/>
+          <p:nvPr/>
+        </p:nvSpPr>
+        <p:spPr>
+          <a:xfrm>
+            <a:off x="6675120" y="3383280"/>
+            <a:ext cx="457200" cy="365760"/>
+          </a:xfrm>
+          <a:prstGeom prst="rect">
+            <a:avLst/>
+          </a:prstGeom>
+          <a:noFill/>
+        </p:spPr>
+        <p:txBody>
+          <a:bodyPr wrap="square">
+            <a:spAutoFit/>
+          </a:bodyPr>
+          <a:lstStyle/>
+          <a:p>
+            <a:pPr algn="ctr">
+              <a:defRPr sz="2200" b="0">
+                <a:solidFill>
+                  <a:srgbClr val="607DB8"/>
+                </a:solidFill>
+                <a:latin typeface="Arial"/>
+              </a:defRPr>
+            </a:pPr>
+            <a:r>
+              <a:t>→</a:t>
+            </a:r>
+          </a:p>
+        </p:txBody>
+      </p:sp>
+      <p:sp>
+        <p:nvSpPr>
+          <p:cNvPr id="33" name="Rounded Rectangle 32"/>
+          <p:cNvSpPr/>
+          <p:nvPr/>
+        </p:nvSpPr>
+        <p:spPr>
+          <a:xfrm>
+            <a:off x="7132320" y="3200400"/>
+            <a:ext cx="2011680" cy="777240"/>
           </a:xfrm>
           <a:prstGeom prst="roundRect">
             <a:avLst>
@@ -4745,28 +5561,28 @@
       </p:sp>
       <p:sp>
         <p:nvSpPr>
-          <p:cNvPr id="13" name="TextBox 12"/>
-          <p:cNvSpPr txBox="1"/>
-          <p:nvPr/>
-        </p:nvSpPr>
-        <p:spPr>
-          <a:xfrm>
-            <a:off x="6507327" y="2788920"/>
-            <a:ext cx="2194560" cy="548640"/>
-          </a:xfrm>
-          <a:prstGeom prst="rect">
-            <a:avLst/>
-          </a:prstGeom>
-          <a:noFill/>
-        </p:spPr>
-        <p:txBody>
-          <a:bodyPr wrap="square">
-            <a:spAutoFit/>
-          </a:bodyPr>
-          <a:lstStyle/>
-          <a:p>
-            <a:pPr algn="ctr">
-              <a:defRPr sz="2000" b="1">
+          <p:cNvPr id="34" name="TextBox 33"/>
+          <p:cNvSpPr txBox="1"/>
+          <p:nvPr/>
+        </p:nvSpPr>
+        <p:spPr>
+          <a:xfrm>
+            <a:off x="7132320" y="3316986"/>
+            <a:ext cx="2011680" cy="349758"/>
+          </a:xfrm>
+          <a:prstGeom prst="rect">
+            <a:avLst/>
+          </a:prstGeom>
+          <a:noFill/>
+        </p:spPr>
+        <p:txBody>
+          <a:bodyPr wrap="square">
+            <a:spAutoFit/>
+          </a:bodyPr>
+          <a:lstStyle/>
+          <a:p>
+            <a:pPr algn="ctr">
+              <a:defRPr sz="1400" b="1">
                 <a:solidFill>
                   <a:srgbClr val="FFFFFF"/>
                 </a:solidFill>
@@ -4781,28 +5597,28 @@
       </p:sp>
       <p:sp>
         <p:nvSpPr>
-          <p:cNvPr id="14" name="TextBox 13"/>
-          <p:cNvSpPr txBox="1"/>
-          <p:nvPr/>
-        </p:nvSpPr>
-        <p:spPr>
-          <a:xfrm>
-            <a:off x="6507327" y="3246120"/>
-            <a:ext cx="2194560" cy="365760"/>
-          </a:xfrm>
-          <a:prstGeom prst="rect">
-            <a:avLst/>
-          </a:prstGeom>
-          <a:noFill/>
-        </p:spPr>
-        <p:txBody>
-          <a:bodyPr wrap="square">
-            <a:spAutoFit/>
-          </a:bodyPr>
-          <a:lstStyle/>
-          <a:p>
-            <a:pPr algn="ctr">
-              <a:defRPr sz="1300" b="0">
+          <p:cNvPr id="35" name="TextBox 34"/>
+          <p:cNvSpPr txBox="1"/>
+          <p:nvPr/>
+        </p:nvSpPr>
+        <p:spPr>
+          <a:xfrm>
+            <a:off x="7132320" y="3589020"/>
+            <a:ext cx="2011680" cy="310896"/>
+          </a:xfrm>
+          <a:prstGeom prst="rect">
+            <a:avLst/>
+          </a:prstGeom>
+          <a:noFill/>
+        </p:spPr>
+        <p:txBody>
+          <a:bodyPr wrap="square">
+            <a:spAutoFit/>
+          </a:bodyPr>
+          <a:lstStyle/>
+          <a:p>
+            <a:pPr algn="ctr">
+              <a:defRPr sz="900" b="0">
                 <a:solidFill>
                   <a:srgbClr val="FFFFFF"/>
                 </a:solidFill>
@@ -4810,35 +5626,35 @@
               </a:defRPr>
             </a:pPr>
             <a:r>
-              <a:t>Brain scoring</a:t>
-            </a:r>
-          </a:p>
-        </p:txBody>
-      </p:sp>
-      <p:sp>
-        <p:nvSpPr>
-          <p:cNvPr id="15" name="TextBox 14"/>
-          <p:cNvSpPr txBox="1"/>
-          <p:nvPr/>
-        </p:nvSpPr>
-        <p:spPr>
-          <a:xfrm>
-            <a:off x="8747607" y="2834639"/>
-            <a:ext cx="548640" cy="731520"/>
-          </a:xfrm>
-          <a:prstGeom prst="rect">
-            <a:avLst/>
-          </a:prstGeom>
-          <a:noFill/>
-        </p:spPr>
-        <p:txBody>
-          <a:bodyPr wrap="square">
-            <a:spAutoFit/>
-          </a:bodyPr>
-          <a:lstStyle/>
-          <a:p>
-            <a:pPr algn="ctr">
-              <a:defRPr sz="3200" b="0">
+              <a:t>Brain encoder</a:t>
+            </a:r>
+          </a:p>
+        </p:txBody>
+      </p:sp>
+      <p:sp>
+        <p:nvSpPr>
+          <p:cNvPr id="36" name="TextBox 35"/>
+          <p:cNvSpPr txBox="1"/>
+          <p:nvPr/>
+        </p:nvSpPr>
+        <p:spPr>
+          <a:xfrm>
+            <a:off x="9235440" y="3383280"/>
+            <a:ext cx="457200" cy="365760"/>
+          </a:xfrm>
+          <a:prstGeom prst="rect">
+            <a:avLst/>
+          </a:prstGeom>
+          <a:noFill/>
+        </p:spPr>
+        <p:txBody>
+          <a:bodyPr wrap="square">
+            <a:spAutoFit/>
+          </a:bodyPr>
+          <a:lstStyle/>
+          <a:p>
+            <a:pPr algn="ctr">
+              <a:defRPr sz="2200" b="0">
                 <a:solidFill>
                   <a:srgbClr val="607DB8"/>
                 </a:solidFill>
@@ -4853,18 +5669,324 @@
       </p:sp>
       <p:sp>
         <p:nvSpPr>
-          <p:cNvPr id="16" name="Rounded Rectangle 15"/>
+          <p:cNvPr id="37" name="Rounded Rectangle 36"/>
           <p:cNvSpPr/>
           <p:nvPr/>
         </p:nvSpPr>
         <p:spPr>
           <a:xfrm>
-            <a:off x="9524847" y="2560320"/>
-            <a:ext cx="2194560" cy="1280160"/>
+            <a:off x="9692640" y="3200400"/>
+            <a:ext cx="2103120" cy="777240"/>
           </a:xfrm>
           <a:prstGeom prst="roundRect">
             <a:avLst>
               <a:gd name="adj" fmla="val 10000"/>
+            </a:avLst>
+          </a:prstGeom>
+          <a:solidFill>
+            <a:srgbClr val="FBBF24"/>
+          </a:solidFill>
+          <a:ln>
+            <a:noFill/>
+          </a:ln>
+        </p:spPr>
+        <p:style>
+          <a:lnRef idx="1">
+            <a:schemeClr val="accent1"/>
+          </a:lnRef>
+          <a:fillRef idx="3">
+            <a:schemeClr val="accent1"/>
+          </a:fillRef>
+          <a:effectRef idx="2">
+            <a:schemeClr val="accent1"/>
+          </a:effectRef>
+          <a:fontRef idx="minor">
+            <a:schemeClr val="lt1"/>
+          </a:fontRef>
+        </p:style>
+        <p:txBody>
+          <a:bodyPr rtlCol="0" anchor="ctr"/>
+          <a:lstStyle/>
+          <a:p>
+            <a:pPr algn="ctr"/>
+          </a:p>
+        </p:txBody>
+      </p:sp>
+      <p:sp>
+        <p:nvSpPr>
+          <p:cNvPr id="38" name="TextBox 37"/>
+          <p:cNvSpPr txBox="1"/>
+          <p:nvPr/>
+        </p:nvSpPr>
+        <p:spPr>
+          <a:xfrm>
+            <a:off x="9692640" y="3316986"/>
+            <a:ext cx="2103120" cy="349758"/>
+          </a:xfrm>
+          <a:prstGeom prst="rect">
+            <a:avLst/>
+          </a:prstGeom>
+          <a:noFill/>
+        </p:spPr>
+        <p:txBody>
+          <a:bodyPr wrap="square">
+            <a:spAutoFit/>
+          </a:bodyPr>
+          <a:lstStyle/>
+          <a:p>
+            <a:pPr algn="ctr">
+              <a:defRPr sz="1200" b="1">
+                <a:solidFill>
+                  <a:srgbClr val="FFFFFF"/>
+                </a:solidFill>
+                <a:latin typeface="Arial"/>
+              </a:defRPr>
+            </a:pPr>
+            <a:r>
+              <a:t>20,484 vertices</a:t>
+            </a:r>
+          </a:p>
+        </p:txBody>
+      </p:sp>
+      <p:sp>
+        <p:nvSpPr>
+          <p:cNvPr id="39" name="TextBox 38"/>
+          <p:cNvSpPr txBox="1"/>
+          <p:nvPr/>
+        </p:nvSpPr>
+        <p:spPr>
+          <a:xfrm>
+            <a:off x="9692640" y="3589020"/>
+            <a:ext cx="2103120" cy="310896"/>
+          </a:xfrm>
+          <a:prstGeom prst="rect">
+            <a:avLst/>
+          </a:prstGeom>
+          <a:noFill/>
+        </p:spPr>
+        <p:txBody>
+          <a:bodyPr wrap="square">
+            <a:spAutoFit/>
+          </a:bodyPr>
+          <a:lstStyle/>
+          <a:p>
+            <a:pPr algn="ctr">
+              <a:defRPr sz="900" b="0">
+                <a:solidFill>
+                  <a:srgbClr val="FFFFFF"/>
+                </a:solidFill>
+                <a:latin typeface="Arial"/>
+              </a:defRPr>
+            </a:pPr>
+            <a:r>
+              <a:t>(T, 20484) activations</a:t>
+            </a:r>
+          </a:p>
+        </p:txBody>
+      </p:sp>
+      <p:sp>
+        <p:nvSpPr>
+          <p:cNvPr id="40" name="TextBox 39"/>
+          <p:cNvSpPr txBox="1"/>
+          <p:nvPr/>
+        </p:nvSpPr>
+        <p:spPr>
+          <a:xfrm>
+            <a:off x="365760" y="4206240"/>
+            <a:ext cx="1828800" cy="365760"/>
+          </a:xfrm>
+          <a:prstGeom prst="rect">
+            <a:avLst/>
+          </a:prstGeom>
+          <a:noFill/>
+        </p:spPr>
+        <p:txBody>
+          <a:bodyPr wrap="square">
+            <a:spAutoFit/>
+          </a:bodyPr>
+          <a:lstStyle/>
+          <a:p>
+            <a:pPr algn="l">
+              <a:defRPr sz="1000" b="1">
+                <a:solidFill>
+                  <a:srgbClr val="93AED2"/>
+                </a:solidFill>
+                <a:latin typeface="Arial"/>
+              </a:defRPr>
+            </a:pPr>
+            <a:r>
+              <a:t>SCORING</a:t>
+            </a:r>
+          </a:p>
+        </p:txBody>
+      </p:sp>
+      <p:sp>
+        <p:nvSpPr>
+          <p:cNvPr id="41" name="Rounded Rectangle 40"/>
+          <p:cNvSpPr/>
+          <p:nvPr/>
+        </p:nvSpPr>
+        <p:spPr>
+          <a:xfrm>
+            <a:off x="731520" y="4526280"/>
+            <a:ext cx="2011680" cy="685800"/>
+          </a:xfrm>
+          <a:prstGeom prst="roundRect">
+            <a:avLst>
+              <a:gd name="adj" fmla="val 10000"/>
+            </a:avLst>
+          </a:prstGeom>
+          <a:solidFill>
+            <a:srgbClr val="64748B"/>
+          </a:solidFill>
+          <a:ln>
+            <a:noFill/>
+          </a:ln>
+        </p:spPr>
+        <p:style>
+          <a:lnRef idx="1">
+            <a:schemeClr val="accent1"/>
+          </a:lnRef>
+          <a:fillRef idx="3">
+            <a:schemeClr val="accent1"/>
+          </a:fillRef>
+          <a:effectRef idx="2">
+            <a:schemeClr val="accent1"/>
+          </a:effectRef>
+          <a:fontRef idx="minor">
+            <a:schemeClr val="lt1"/>
+          </a:fontRef>
+        </p:style>
+        <p:txBody>
+          <a:bodyPr rtlCol="0" anchor="ctr"/>
+          <a:lstStyle/>
+          <a:p>
+            <a:pPr algn="ctr"/>
+          </a:p>
+        </p:txBody>
+      </p:sp>
+      <p:sp>
+        <p:nvSpPr>
+          <p:cNvPr id="42" name="TextBox 41"/>
+          <p:cNvSpPr txBox="1"/>
+          <p:nvPr/>
+        </p:nvSpPr>
+        <p:spPr>
+          <a:xfrm>
+            <a:off x="731520" y="4629150"/>
+            <a:ext cx="2011680" cy="308610"/>
+          </a:xfrm>
+          <a:prstGeom prst="rect">
+            <a:avLst/>
+          </a:prstGeom>
+          <a:noFill/>
+        </p:spPr>
+        <p:txBody>
+          <a:bodyPr wrap="square">
+            <a:spAutoFit/>
+          </a:bodyPr>
+          <a:lstStyle/>
+          <a:p>
+            <a:pPr algn="ctr">
+              <a:defRPr sz="1100" b="1">
+                <a:solidFill>
+                  <a:srgbClr val="FFFFFF"/>
+                </a:solidFill>
+                <a:latin typeface="Arial"/>
+              </a:defRPr>
+            </a:pPr>
+            <a:r>
+              <a:t>Destrieux Atlas</a:t>
+            </a:r>
+          </a:p>
+        </p:txBody>
+      </p:sp>
+      <p:sp>
+        <p:nvSpPr>
+          <p:cNvPr id="43" name="TextBox 42"/>
+          <p:cNvSpPr txBox="1"/>
+          <p:nvPr/>
+        </p:nvSpPr>
+        <p:spPr>
+          <a:xfrm>
+            <a:off x="731520" y="4869180"/>
+            <a:ext cx="2011680" cy="274320"/>
+          </a:xfrm>
+          <a:prstGeom prst="rect">
+            <a:avLst/>
+          </a:prstGeom>
+          <a:noFill/>
+        </p:spPr>
+        <p:txBody>
+          <a:bodyPr wrap="square">
+            <a:spAutoFit/>
+          </a:bodyPr>
+          <a:lstStyle/>
+          <a:p>
+            <a:pPr algn="ctr">
+              <a:defRPr sz="900" b="0">
+                <a:solidFill>
+                  <a:srgbClr val="FFFFFF"/>
+                </a:solidFill>
+                <a:latin typeface="Arial"/>
+              </a:defRPr>
+            </a:pPr>
+            <a:r>
+              <a:t>ROI extraction</a:t>
+            </a:r>
+          </a:p>
+        </p:txBody>
+      </p:sp>
+      <p:sp>
+        <p:nvSpPr>
+          <p:cNvPr id="44" name="TextBox 43"/>
+          <p:cNvSpPr txBox="1"/>
+          <p:nvPr/>
+        </p:nvSpPr>
+        <p:spPr>
+          <a:xfrm>
+            <a:off x="2834640" y="4663440"/>
+            <a:ext cx="365760" cy="365760"/>
+          </a:xfrm>
+          <a:prstGeom prst="rect">
+            <a:avLst/>
+          </a:prstGeom>
+          <a:noFill/>
+        </p:spPr>
+        <p:txBody>
+          <a:bodyPr wrap="square">
+            <a:spAutoFit/>
+          </a:bodyPr>
+          <a:lstStyle/>
+          <a:p>
+            <a:pPr algn="ctr">
+              <a:defRPr sz="2200" b="0">
+                <a:solidFill>
+                  <a:srgbClr val="607DB8"/>
+                </a:solidFill>
+                <a:latin typeface="Arial"/>
+              </a:defRPr>
+            </a:pPr>
+            <a:r>
+              <a:t>→</a:t>
+            </a:r>
+          </a:p>
+        </p:txBody>
+      </p:sp>
+      <p:sp>
+        <p:nvSpPr>
+          <p:cNvPr id="45" name="Rounded Rectangle 44"/>
+          <p:cNvSpPr/>
+          <p:nvPr/>
+        </p:nvSpPr>
+        <p:spPr>
+          <a:xfrm>
+            <a:off x="3291840" y="4526280"/>
+            <a:ext cx="1234440" cy="685800"/>
+          </a:xfrm>
+          <a:prstGeom prst="roundRect">
+            <a:avLst>
+              <a:gd name="adj" fmla="val 15000"/>
             </a:avLst>
           </a:prstGeom>
           <a:solidFill>
@@ -4898,28 +6020,28 @@
       </p:sp>
       <p:sp>
         <p:nvSpPr>
-          <p:cNvPr id="17" name="TextBox 16"/>
-          <p:cNvSpPr txBox="1"/>
-          <p:nvPr/>
-        </p:nvSpPr>
-        <p:spPr>
-          <a:xfrm>
-            <a:off x="9524847" y="2788920"/>
-            <a:ext cx="2194560" cy="548640"/>
-          </a:xfrm>
-          <a:prstGeom prst="rect">
-            <a:avLst/>
-          </a:prstGeom>
-          <a:noFill/>
-        </p:spPr>
-        <p:txBody>
-          <a:bodyPr wrap="square">
-            <a:spAutoFit/>
-          </a:bodyPr>
-          <a:lstStyle/>
-          <a:p>
-            <a:pPr algn="ctr">
-              <a:defRPr sz="2000" b="1">
+          <p:cNvPr id="46" name="TextBox 45"/>
+          <p:cNvSpPr txBox="1"/>
+          <p:nvPr/>
+        </p:nvSpPr>
+        <p:spPr>
+          <a:xfrm>
+            <a:off x="3291840" y="4629150"/>
+            <a:ext cx="1234440" cy="308610"/>
+          </a:xfrm>
+          <a:prstGeom prst="rect">
+            <a:avLst/>
+          </a:prstGeom>
+          <a:noFill/>
+        </p:spPr>
+        <p:txBody>
+          <a:bodyPr wrap="square">
+            <a:spAutoFit/>
+          </a:bodyPr>
+          <a:lstStyle/>
+          <a:p>
+            <a:pPr algn="ctr">
+              <a:defRPr sz="1000" b="1">
                 <a:solidFill>
                   <a:srgbClr val="FFFFFF"/>
                 </a:solidFill>
@@ -4927,35 +6049,35 @@
               </a:defRPr>
             </a:pPr>
             <a:r>
-              <a:t>BrainReach</a:t>
-            </a:r>
-          </a:p>
-        </p:txBody>
-      </p:sp>
-      <p:sp>
-        <p:nvSpPr>
-          <p:cNvPr id="18" name="TextBox 17"/>
-          <p:cNvSpPr txBox="1"/>
-          <p:nvPr/>
-        </p:nvSpPr>
-        <p:spPr>
-          <a:xfrm>
-            <a:off x="9524847" y="3246120"/>
-            <a:ext cx="2194560" cy="365760"/>
-          </a:xfrm>
-          <a:prstGeom prst="rect">
-            <a:avLst/>
-          </a:prstGeom>
-          <a:noFill/>
-        </p:spPr>
-        <p:txBody>
-          <a:bodyPr wrap="square">
-            <a:spAutoFit/>
-          </a:bodyPr>
-          <a:lstStyle/>
-          <a:p>
-            <a:pPr algn="ctr">
-              <a:defRPr sz="1300" b="0">
+              <a:t>Attention</a:t>
+            </a:r>
+          </a:p>
+        </p:txBody>
+      </p:sp>
+      <p:sp>
+        <p:nvSpPr>
+          <p:cNvPr id="47" name="TextBox 46"/>
+          <p:cNvSpPr txBox="1"/>
+          <p:nvPr/>
+        </p:nvSpPr>
+        <p:spPr>
+          <a:xfrm>
+            <a:off x="3291840" y="4869180"/>
+            <a:ext cx="1234440" cy="274320"/>
+          </a:xfrm>
+          <a:prstGeom prst="rect">
+            <a:avLst/>
+          </a:prstGeom>
+          <a:noFill/>
+        </p:spPr>
+        <p:txBody>
+          <a:bodyPr wrap="square">
+            <a:spAutoFit/>
+          </a:bodyPr>
+          <a:lstStyle/>
+          <a:p>
+            <a:pPr algn="ctr">
+              <a:defRPr sz="800" b="0">
                 <a:solidFill>
                   <a:srgbClr val="FFFFFF"/>
                 </a:solidFill>
@@ -4963,25 +6085,1258 @@
               </a:defRPr>
             </a:pPr>
             <a:r>
-              <a:t>Iterate</a:t>
-            </a:r>
-          </a:p>
-        </p:txBody>
-      </p:sp>
-      <p:sp>
-        <p:nvSpPr>
-          <p:cNvPr id="19" name="Rounded Rectangle 18"/>
+              <a:t>Parietal</a:t>
+            </a:r>
+          </a:p>
+        </p:txBody>
+      </p:sp>
+      <p:sp>
+        <p:nvSpPr>
+          <p:cNvPr id="48" name="Rounded Rectangle 47"/>
           <p:cNvSpPr/>
           <p:nvPr/>
         </p:nvSpPr>
         <p:spPr>
           <a:xfrm>
-            <a:off x="2560320" y="4389120"/>
-            <a:ext cx="2011680" cy="640080"/>
+            <a:off x="4617720" y="4526280"/>
+            <a:ext cx="1234440" cy="685800"/>
           </a:xfrm>
           <a:prstGeom prst="roundRect">
             <a:avLst>
               <a:gd name="adj" fmla="val 15000"/>
+            </a:avLst>
+          </a:prstGeom>
+          <a:solidFill>
+            <a:srgbClr val="10B981"/>
+          </a:solidFill>
+          <a:ln>
+            <a:noFill/>
+          </a:ln>
+        </p:spPr>
+        <p:style>
+          <a:lnRef idx="1">
+            <a:schemeClr val="accent1"/>
+          </a:lnRef>
+          <a:fillRef idx="3">
+            <a:schemeClr val="accent1"/>
+          </a:fillRef>
+          <a:effectRef idx="2">
+            <a:schemeClr val="accent1"/>
+          </a:effectRef>
+          <a:fontRef idx="minor">
+            <a:schemeClr val="lt1"/>
+          </a:fontRef>
+        </p:style>
+        <p:txBody>
+          <a:bodyPr rtlCol="0" anchor="ctr"/>
+          <a:lstStyle/>
+          <a:p>
+            <a:pPr algn="ctr"/>
+          </a:p>
+        </p:txBody>
+      </p:sp>
+      <p:sp>
+        <p:nvSpPr>
+          <p:cNvPr id="49" name="TextBox 48"/>
+          <p:cNvSpPr txBox="1"/>
+          <p:nvPr/>
+        </p:nvSpPr>
+        <p:spPr>
+          <a:xfrm>
+            <a:off x="4617720" y="4629150"/>
+            <a:ext cx="1234440" cy="308610"/>
+          </a:xfrm>
+          <a:prstGeom prst="rect">
+            <a:avLst/>
+          </a:prstGeom>
+          <a:noFill/>
+        </p:spPr>
+        <p:txBody>
+          <a:bodyPr wrap="square">
+            <a:spAutoFit/>
+          </a:bodyPr>
+          <a:lstStyle/>
+          <a:p>
+            <a:pPr algn="ctr">
+              <a:defRPr sz="1000" b="1">
+                <a:solidFill>
+                  <a:srgbClr val="FFFFFF"/>
+                </a:solidFill>
+                <a:latin typeface="Arial"/>
+              </a:defRPr>
+            </a:pPr>
+            <a:r>
+              <a:t>Curiosity</a:t>
+            </a:r>
+          </a:p>
+        </p:txBody>
+      </p:sp>
+      <p:sp>
+        <p:nvSpPr>
+          <p:cNvPr id="50" name="TextBox 49"/>
+          <p:cNvSpPr txBox="1"/>
+          <p:nvPr/>
+        </p:nvSpPr>
+        <p:spPr>
+          <a:xfrm>
+            <a:off x="4617720" y="4869180"/>
+            <a:ext cx="1234440" cy="274320"/>
+          </a:xfrm>
+          <a:prstGeom prst="rect">
+            <a:avLst/>
+          </a:prstGeom>
+          <a:noFill/>
+        </p:spPr>
+        <p:txBody>
+          <a:bodyPr wrap="square">
+            <a:spAutoFit/>
+          </a:bodyPr>
+          <a:lstStyle/>
+          <a:p>
+            <a:pPr algn="ctr">
+              <a:defRPr sz="800" b="0">
+                <a:solidFill>
+                  <a:srgbClr val="FFFFFF"/>
+                </a:solidFill>
+                <a:latin typeface="Arial"/>
+              </a:defRPr>
+            </a:pPr>
+            <a:r>
+              <a:t>Ant. cingulate</a:t>
+            </a:r>
+          </a:p>
+        </p:txBody>
+      </p:sp>
+      <p:sp>
+        <p:nvSpPr>
+          <p:cNvPr id="51" name="Rounded Rectangle 50"/>
+          <p:cNvSpPr/>
+          <p:nvPr/>
+        </p:nvSpPr>
+        <p:spPr>
+          <a:xfrm>
+            <a:off x="5943600" y="4526280"/>
+            <a:ext cx="1234440" cy="685800"/>
+          </a:xfrm>
+          <a:prstGeom prst="roundRect">
+            <a:avLst>
+              <a:gd name="adj" fmla="val 15000"/>
+            </a:avLst>
+          </a:prstGeom>
+          <a:solidFill>
+            <a:srgbClr val="10B981"/>
+          </a:solidFill>
+          <a:ln>
+            <a:noFill/>
+          </a:ln>
+        </p:spPr>
+        <p:style>
+          <a:lnRef idx="1">
+            <a:schemeClr val="accent1"/>
+          </a:lnRef>
+          <a:fillRef idx="3">
+            <a:schemeClr val="accent1"/>
+          </a:fillRef>
+          <a:effectRef idx="2">
+            <a:schemeClr val="accent1"/>
+          </a:effectRef>
+          <a:fontRef idx="minor">
+            <a:schemeClr val="lt1"/>
+          </a:fontRef>
+        </p:style>
+        <p:txBody>
+          <a:bodyPr rtlCol="0" anchor="ctr"/>
+          <a:lstStyle/>
+          <a:p>
+            <a:pPr algn="ctr"/>
+          </a:p>
+        </p:txBody>
+      </p:sp>
+      <p:sp>
+        <p:nvSpPr>
+          <p:cNvPr id="52" name="TextBox 51"/>
+          <p:cNvSpPr txBox="1"/>
+          <p:nvPr/>
+        </p:nvSpPr>
+        <p:spPr>
+          <a:xfrm>
+            <a:off x="5943600" y="4629150"/>
+            <a:ext cx="1234440" cy="308610"/>
+          </a:xfrm>
+          <a:prstGeom prst="rect">
+            <a:avLst/>
+          </a:prstGeom>
+          <a:noFill/>
+        </p:spPr>
+        <p:txBody>
+          <a:bodyPr wrap="square">
+            <a:spAutoFit/>
+          </a:bodyPr>
+          <a:lstStyle/>
+          <a:p>
+            <a:pPr algn="ctr">
+              <a:defRPr sz="1000" b="1">
+                <a:solidFill>
+                  <a:srgbClr val="FFFFFF"/>
+                </a:solidFill>
+                <a:latin typeface="Arial"/>
+              </a:defRPr>
+            </a:pPr>
+            <a:r>
+              <a:t>Trust</a:t>
+            </a:r>
+          </a:p>
+        </p:txBody>
+      </p:sp>
+      <p:sp>
+        <p:nvSpPr>
+          <p:cNvPr id="53" name="TextBox 52"/>
+          <p:cNvSpPr txBox="1"/>
+          <p:nvPr/>
+        </p:nvSpPr>
+        <p:spPr>
+          <a:xfrm>
+            <a:off x="5943600" y="4869180"/>
+            <a:ext cx="1234440" cy="274320"/>
+          </a:xfrm>
+          <a:prstGeom prst="rect">
+            <a:avLst/>
+          </a:prstGeom>
+          <a:noFill/>
+        </p:spPr>
+        <p:txBody>
+          <a:bodyPr wrap="square">
+            <a:spAutoFit/>
+          </a:bodyPr>
+          <a:lstStyle/>
+          <a:p>
+            <a:pPr algn="ctr">
+              <a:defRPr sz="800" b="0">
+                <a:solidFill>
+                  <a:srgbClr val="FFFFFF"/>
+                </a:solidFill>
+                <a:latin typeface="Arial"/>
+              </a:defRPr>
+            </a:pPr>
+            <a:r>
+              <a:t>TPJ</a:t>
+            </a:r>
+          </a:p>
+        </p:txBody>
+      </p:sp>
+      <p:sp>
+        <p:nvSpPr>
+          <p:cNvPr id="54" name="Rounded Rectangle 53"/>
+          <p:cNvSpPr/>
+          <p:nvPr/>
+        </p:nvSpPr>
+        <p:spPr>
+          <a:xfrm>
+            <a:off x="7269480" y="4526280"/>
+            <a:ext cx="1234440" cy="685800"/>
+          </a:xfrm>
+          <a:prstGeom prst="roundRect">
+            <a:avLst>
+              <a:gd name="adj" fmla="val 15000"/>
+            </a:avLst>
+          </a:prstGeom>
+          <a:solidFill>
+            <a:srgbClr val="10B981"/>
+          </a:solidFill>
+          <a:ln>
+            <a:noFill/>
+          </a:ln>
+        </p:spPr>
+        <p:style>
+          <a:lnRef idx="1">
+            <a:schemeClr val="accent1"/>
+          </a:lnRef>
+          <a:fillRef idx="3">
+            <a:schemeClr val="accent1"/>
+          </a:fillRef>
+          <a:effectRef idx="2">
+            <a:schemeClr val="accent1"/>
+          </a:effectRef>
+          <a:fontRef idx="minor">
+            <a:schemeClr val="lt1"/>
+          </a:fontRef>
+        </p:style>
+        <p:txBody>
+          <a:bodyPr rtlCol="0" anchor="ctr"/>
+          <a:lstStyle/>
+          <a:p>
+            <a:pPr algn="ctr"/>
+          </a:p>
+        </p:txBody>
+      </p:sp>
+      <p:sp>
+        <p:nvSpPr>
+          <p:cNvPr id="55" name="TextBox 54"/>
+          <p:cNvSpPr txBox="1"/>
+          <p:nvPr/>
+        </p:nvSpPr>
+        <p:spPr>
+          <a:xfrm>
+            <a:off x="7269480" y="4629150"/>
+            <a:ext cx="1234440" cy="308610"/>
+          </a:xfrm>
+          <a:prstGeom prst="rect">
+            <a:avLst/>
+          </a:prstGeom>
+          <a:noFill/>
+        </p:spPr>
+        <p:txBody>
+          <a:bodyPr wrap="square">
+            <a:spAutoFit/>
+          </a:bodyPr>
+          <a:lstStyle/>
+          <a:p>
+            <a:pPr algn="ctr">
+              <a:defRPr sz="1000" b="1">
+                <a:solidFill>
+                  <a:srgbClr val="FFFFFF"/>
+                </a:solidFill>
+                <a:latin typeface="Arial"/>
+              </a:defRPr>
+            </a:pPr>
+            <a:r>
+              <a:t>Motivation</a:t>
+            </a:r>
+          </a:p>
+        </p:txBody>
+      </p:sp>
+      <p:sp>
+        <p:nvSpPr>
+          <p:cNvPr id="56" name="TextBox 55"/>
+          <p:cNvSpPr txBox="1"/>
+          <p:nvPr/>
+        </p:nvSpPr>
+        <p:spPr>
+          <a:xfrm>
+            <a:off x="7269480" y="4869180"/>
+            <a:ext cx="1234440" cy="274320"/>
+          </a:xfrm>
+          <a:prstGeom prst="rect">
+            <a:avLst/>
+          </a:prstGeom>
+          <a:noFill/>
+        </p:spPr>
+        <p:txBody>
+          <a:bodyPr wrap="square">
+            <a:spAutoFit/>
+          </a:bodyPr>
+          <a:lstStyle/>
+          <a:p>
+            <a:pPr algn="ctr">
+              <a:defRPr sz="800" b="0">
+                <a:solidFill>
+                  <a:srgbClr val="FFFFFF"/>
+                </a:solidFill>
+                <a:latin typeface="Arial"/>
+              </a:defRPr>
+            </a:pPr>
+            <a:r>
+              <a:t>vmPFC</a:t>
+            </a:r>
+          </a:p>
+        </p:txBody>
+      </p:sp>
+      <p:sp>
+        <p:nvSpPr>
+          <p:cNvPr id="57" name="Rounded Rectangle 56"/>
+          <p:cNvSpPr/>
+          <p:nvPr/>
+        </p:nvSpPr>
+        <p:spPr>
+          <a:xfrm>
+            <a:off x="8595360" y="4526280"/>
+            <a:ext cx="1234440" cy="685800"/>
+          </a:xfrm>
+          <a:prstGeom prst="roundRect">
+            <a:avLst>
+              <a:gd name="adj" fmla="val 15000"/>
+            </a:avLst>
+          </a:prstGeom>
+          <a:solidFill>
+            <a:srgbClr val="FB7185"/>
+          </a:solidFill>
+          <a:ln>
+            <a:noFill/>
+          </a:ln>
+        </p:spPr>
+        <p:style>
+          <a:lnRef idx="1">
+            <a:schemeClr val="accent1"/>
+          </a:lnRef>
+          <a:fillRef idx="3">
+            <a:schemeClr val="accent1"/>
+          </a:fillRef>
+          <a:effectRef idx="2">
+            <a:schemeClr val="accent1"/>
+          </a:effectRef>
+          <a:fontRef idx="minor">
+            <a:schemeClr val="lt1"/>
+          </a:fontRef>
+        </p:style>
+        <p:txBody>
+          <a:bodyPr rtlCol="0" anchor="ctr"/>
+          <a:lstStyle/>
+          <a:p>
+            <a:pPr algn="ctr"/>
+          </a:p>
+        </p:txBody>
+      </p:sp>
+      <p:sp>
+        <p:nvSpPr>
+          <p:cNvPr id="58" name="TextBox 57"/>
+          <p:cNvSpPr txBox="1"/>
+          <p:nvPr/>
+        </p:nvSpPr>
+        <p:spPr>
+          <a:xfrm>
+            <a:off x="8595360" y="4629150"/>
+            <a:ext cx="1234440" cy="308610"/>
+          </a:xfrm>
+          <a:prstGeom prst="rect">
+            <a:avLst/>
+          </a:prstGeom>
+          <a:noFill/>
+        </p:spPr>
+        <p:txBody>
+          <a:bodyPr wrap="square">
+            <a:spAutoFit/>
+          </a:bodyPr>
+          <a:lstStyle/>
+          <a:p>
+            <a:pPr algn="ctr">
+              <a:defRPr sz="1000" b="1">
+                <a:solidFill>
+                  <a:srgbClr val="FFFFFF"/>
+                </a:solidFill>
+                <a:latin typeface="Arial"/>
+              </a:defRPr>
+            </a:pPr>
+            <a:r>
+              <a:t>Resistance</a:t>
+            </a:r>
+          </a:p>
+        </p:txBody>
+      </p:sp>
+      <p:sp>
+        <p:nvSpPr>
+          <p:cNvPr id="59" name="TextBox 58"/>
+          <p:cNvSpPr txBox="1"/>
+          <p:nvPr/>
+        </p:nvSpPr>
+        <p:spPr>
+          <a:xfrm>
+            <a:off x="8595360" y="4869180"/>
+            <a:ext cx="1234440" cy="274320"/>
+          </a:xfrm>
+          <a:prstGeom prst="rect">
+            <a:avLst/>
+          </a:prstGeom>
+          <a:noFill/>
+        </p:spPr>
+        <p:txBody>
+          <a:bodyPr wrap="square">
+            <a:spAutoFit/>
+          </a:bodyPr>
+          <a:lstStyle/>
+          <a:p>
+            <a:pPr algn="ctr">
+              <a:defRPr sz="800" b="0">
+                <a:solidFill>
+                  <a:srgbClr val="FFFFFF"/>
+                </a:solidFill>
+                <a:latin typeface="Arial"/>
+              </a:defRPr>
+            </a:pPr>
+            <a:r>
+              <a:t>Insula</a:t>
+            </a:r>
+          </a:p>
+        </p:txBody>
+      </p:sp>
+      <p:sp>
+        <p:nvSpPr>
+          <p:cNvPr id="60" name="TextBox 59"/>
+          <p:cNvSpPr txBox="1"/>
+          <p:nvPr/>
+        </p:nvSpPr>
+        <p:spPr>
+          <a:xfrm>
+            <a:off x="9921240" y="4663440"/>
+            <a:ext cx="365760" cy="365760"/>
+          </a:xfrm>
+          <a:prstGeom prst="rect">
+            <a:avLst/>
+          </a:prstGeom>
+          <a:noFill/>
+        </p:spPr>
+        <p:txBody>
+          <a:bodyPr wrap="square">
+            <a:spAutoFit/>
+          </a:bodyPr>
+          <a:lstStyle/>
+          <a:p>
+            <a:pPr algn="ctr">
+              <a:defRPr sz="2200" b="0">
+                <a:solidFill>
+                  <a:srgbClr val="607DB8"/>
+                </a:solidFill>
+                <a:latin typeface="Arial"/>
+              </a:defRPr>
+            </a:pPr>
+            <a:r>
+              <a:t>→</a:t>
+            </a:r>
+          </a:p>
+        </p:txBody>
+      </p:sp>
+      <p:sp>
+        <p:nvSpPr>
+          <p:cNvPr id="61" name="Rounded Rectangle 60"/>
+          <p:cNvSpPr/>
+          <p:nvPr/>
+        </p:nvSpPr>
+        <p:spPr>
+          <a:xfrm>
+            <a:off x="10287000" y="4526280"/>
+            <a:ext cx="1463040" cy="685800"/>
+          </a:xfrm>
+          <a:prstGeom prst="roundRect">
+            <a:avLst>
+              <a:gd name="adj" fmla="val 10000"/>
+            </a:avLst>
+          </a:prstGeom>
+          <a:solidFill>
+            <a:srgbClr val="FBBF24"/>
+          </a:solidFill>
+          <a:ln>
+            <a:noFill/>
+          </a:ln>
+        </p:spPr>
+        <p:style>
+          <a:lnRef idx="1">
+            <a:schemeClr val="accent1"/>
+          </a:lnRef>
+          <a:fillRef idx="3">
+            <a:schemeClr val="accent1"/>
+          </a:fillRef>
+          <a:effectRef idx="2">
+            <a:schemeClr val="accent1"/>
+          </a:effectRef>
+          <a:fontRef idx="minor">
+            <a:schemeClr val="lt1"/>
+          </a:fontRef>
+        </p:style>
+        <p:txBody>
+          <a:bodyPr rtlCol="0" anchor="ctr"/>
+          <a:lstStyle/>
+          <a:p>
+            <a:pPr algn="ctr"/>
+          </a:p>
+        </p:txBody>
+      </p:sp>
+      <p:sp>
+        <p:nvSpPr>
+          <p:cNvPr id="62" name="TextBox 61"/>
+          <p:cNvSpPr txBox="1"/>
+          <p:nvPr/>
+        </p:nvSpPr>
+        <p:spPr>
+          <a:xfrm>
+            <a:off x="10287000" y="4629150"/>
+            <a:ext cx="1463040" cy="308610"/>
+          </a:xfrm>
+          <a:prstGeom prst="rect">
+            <a:avLst/>
+          </a:prstGeom>
+          <a:noFill/>
+        </p:spPr>
+        <p:txBody>
+          <a:bodyPr wrap="square">
+            <a:spAutoFit/>
+          </a:bodyPr>
+          <a:lstStyle/>
+          <a:p>
+            <a:pPr algn="ctr">
+              <a:defRPr sz="1100" b="1">
+                <a:solidFill>
+                  <a:srgbClr val="FFFFFF"/>
+                </a:solidFill>
+                <a:latin typeface="Arial"/>
+              </a:defRPr>
+            </a:pPr>
+            <a:r>
+              <a:t>Kahneman</a:t>
+            </a:r>
+          </a:p>
+        </p:txBody>
+      </p:sp>
+      <p:sp>
+        <p:nvSpPr>
+          <p:cNvPr id="63" name="TextBox 62"/>
+          <p:cNvSpPr txBox="1"/>
+          <p:nvPr/>
+        </p:nvSpPr>
+        <p:spPr>
+          <a:xfrm>
+            <a:off x="10287000" y="4869180"/>
+            <a:ext cx="1463040" cy="274320"/>
+          </a:xfrm>
+          <a:prstGeom prst="rect">
+            <a:avLst/>
+          </a:prstGeom>
+          <a:noFill/>
+        </p:spPr>
+        <p:txBody>
+          <a:bodyPr wrap="square">
+            <a:spAutoFit/>
+          </a:bodyPr>
+          <a:lstStyle/>
+          <a:p>
+            <a:pPr algn="ctr">
+              <a:defRPr sz="900" b="0">
+                <a:solidFill>
+                  <a:srgbClr val="FFFFFF"/>
+                </a:solidFill>
+                <a:latin typeface="Arial"/>
+              </a:defRPr>
+            </a:pPr>
+            <a:r>
+              <a:t>Peak-end rule</a:t>
+            </a:r>
+          </a:p>
+        </p:txBody>
+      </p:sp>
+      <p:sp>
+        <p:nvSpPr>
+          <p:cNvPr id="64" name="TextBox 63"/>
+          <p:cNvSpPr txBox="1"/>
+          <p:nvPr/>
+        </p:nvSpPr>
+        <p:spPr>
+          <a:xfrm>
+            <a:off x="365760" y="5440680"/>
+            <a:ext cx="1828800" cy="365760"/>
+          </a:xfrm>
+          <a:prstGeom prst="rect">
+            <a:avLst/>
+          </a:prstGeom>
+          <a:noFill/>
+        </p:spPr>
+        <p:txBody>
+          <a:bodyPr wrap="square">
+            <a:spAutoFit/>
+          </a:bodyPr>
+          <a:lstStyle/>
+          <a:p>
+            <a:pPr algn="l">
+              <a:defRPr sz="1000" b="1">
+                <a:solidFill>
+                  <a:srgbClr val="93AED2"/>
+                </a:solidFill>
+                <a:latin typeface="Arial"/>
+              </a:defRPr>
+            </a:pPr>
+            <a:r>
+              <a:t>INFRASTRUCTURE</a:t>
+            </a:r>
+          </a:p>
+        </p:txBody>
+      </p:sp>
+      <p:sp>
+        <p:nvSpPr>
+          <p:cNvPr id="65" name="Rounded Rectangle 64"/>
+          <p:cNvSpPr/>
+          <p:nvPr/>
+        </p:nvSpPr>
+        <p:spPr>
+          <a:xfrm>
+            <a:off x="731520" y="5760720"/>
+            <a:ext cx="2011680" cy="594360"/>
+          </a:xfrm>
+          <a:prstGeom prst="roundRect">
+            <a:avLst>
+              <a:gd name="adj" fmla="val 10000"/>
+            </a:avLst>
+          </a:prstGeom>
+          <a:solidFill>
+            <a:srgbClr val="474E68"/>
+          </a:solidFill>
+          <a:ln>
+            <a:noFill/>
+          </a:ln>
+        </p:spPr>
+        <p:style>
+          <a:lnRef idx="1">
+            <a:schemeClr val="accent1"/>
+          </a:lnRef>
+          <a:fillRef idx="3">
+            <a:schemeClr val="accent1"/>
+          </a:fillRef>
+          <a:effectRef idx="2">
+            <a:schemeClr val="accent1"/>
+          </a:effectRef>
+          <a:fontRef idx="minor">
+            <a:schemeClr val="lt1"/>
+          </a:fontRef>
+        </p:style>
+        <p:txBody>
+          <a:bodyPr rtlCol="0" anchor="ctr"/>
+          <a:lstStyle/>
+          <a:p>
+            <a:pPr algn="ctr"/>
+          </a:p>
+        </p:txBody>
+      </p:sp>
+      <p:sp>
+        <p:nvSpPr>
+          <p:cNvPr id="66" name="TextBox 65"/>
+          <p:cNvSpPr txBox="1"/>
+          <p:nvPr/>
+        </p:nvSpPr>
+        <p:spPr>
+          <a:xfrm>
+            <a:off x="731520" y="5879592"/>
+            <a:ext cx="2011680" cy="356616"/>
+          </a:xfrm>
+          <a:prstGeom prst="rect">
+            <a:avLst/>
+          </a:prstGeom>
+          <a:noFill/>
+        </p:spPr>
+        <p:txBody>
+          <a:bodyPr wrap="square">
+            <a:spAutoFit/>
+          </a:bodyPr>
+          <a:lstStyle/>
+          <a:p>
+            <a:pPr algn="ctr">
+              <a:defRPr sz="1200" b="1">
+                <a:solidFill>
+                  <a:srgbClr val="FFFFFF"/>
+                </a:solidFill>
+                <a:latin typeface="Arial"/>
+              </a:defRPr>
+            </a:pPr>
+            <a:r>
+              <a:t>CoreWeave Cloud</a:t>
+            </a:r>
+          </a:p>
+        </p:txBody>
+      </p:sp>
+      <p:sp>
+        <p:nvSpPr>
+          <p:cNvPr id="67" name="TextBox 66"/>
+          <p:cNvSpPr txBox="1"/>
+          <p:nvPr/>
+        </p:nvSpPr>
+        <p:spPr>
+          <a:xfrm>
+            <a:off x="2834640" y="5852159"/>
+            <a:ext cx="365760" cy="365760"/>
+          </a:xfrm>
+          <a:prstGeom prst="rect">
+            <a:avLst/>
+          </a:prstGeom>
+          <a:noFill/>
+        </p:spPr>
+        <p:txBody>
+          <a:bodyPr wrap="square">
+            <a:spAutoFit/>
+          </a:bodyPr>
+          <a:lstStyle/>
+          <a:p>
+            <a:pPr algn="ctr">
+              <a:defRPr sz="2200" b="0">
+                <a:solidFill>
+                  <a:srgbClr val="607DB8"/>
+                </a:solidFill>
+                <a:latin typeface="Arial"/>
+              </a:defRPr>
+            </a:pPr>
+            <a:r>
+              <a:t>→</a:t>
+            </a:r>
+          </a:p>
+        </p:txBody>
+      </p:sp>
+      <p:sp>
+        <p:nvSpPr>
+          <p:cNvPr id="68" name="Rounded Rectangle 67"/>
+          <p:cNvSpPr/>
+          <p:nvPr/>
+        </p:nvSpPr>
+        <p:spPr>
+          <a:xfrm>
+            <a:off x="3200400" y="5760720"/>
+            <a:ext cx="2286000" cy="594360"/>
+          </a:xfrm>
+          <a:prstGeom prst="roundRect">
+            <a:avLst>
+              <a:gd name="adj" fmla="val 10000"/>
+            </a:avLst>
+          </a:prstGeom>
+          <a:solidFill>
+            <a:srgbClr val="76B900"/>
+          </a:solidFill>
+          <a:ln>
+            <a:noFill/>
+          </a:ln>
+        </p:spPr>
+        <p:style>
+          <a:lnRef idx="1">
+            <a:schemeClr val="accent1"/>
+          </a:lnRef>
+          <a:fillRef idx="3">
+            <a:schemeClr val="accent1"/>
+          </a:fillRef>
+          <a:effectRef idx="2">
+            <a:schemeClr val="accent1"/>
+          </a:effectRef>
+          <a:fontRef idx="minor">
+            <a:schemeClr val="lt1"/>
+          </a:fontRef>
+        </p:style>
+        <p:txBody>
+          <a:bodyPr rtlCol="0" anchor="ctr"/>
+          <a:lstStyle/>
+          <a:p>
+            <a:pPr algn="ctr"/>
+          </a:p>
+        </p:txBody>
+      </p:sp>
+      <p:sp>
+        <p:nvSpPr>
+          <p:cNvPr id="69" name="TextBox 68"/>
+          <p:cNvSpPr txBox="1"/>
+          <p:nvPr/>
+        </p:nvSpPr>
+        <p:spPr>
+          <a:xfrm>
+            <a:off x="3200400" y="5849874"/>
+            <a:ext cx="2286000" cy="267462"/>
+          </a:xfrm>
+          <a:prstGeom prst="rect">
+            <a:avLst/>
+          </a:prstGeom>
+          <a:noFill/>
+        </p:spPr>
+        <p:txBody>
+          <a:bodyPr wrap="square">
+            <a:spAutoFit/>
+          </a:bodyPr>
+          <a:lstStyle/>
+          <a:p>
+            <a:pPr algn="ctr">
+              <a:defRPr sz="1200" b="1">
+                <a:solidFill>
+                  <a:srgbClr val="FFFFFF"/>
+                </a:solidFill>
+                <a:latin typeface="Arial"/>
+              </a:defRPr>
+            </a:pPr>
+            <a:r>
+              <a:t>NVIDIA B200</a:t>
+            </a:r>
+          </a:p>
+        </p:txBody>
+      </p:sp>
+      <p:sp>
+        <p:nvSpPr>
+          <p:cNvPr id="70" name="TextBox 69"/>
+          <p:cNvSpPr txBox="1"/>
+          <p:nvPr/>
+        </p:nvSpPr>
+        <p:spPr>
+          <a:xfrm>
+            <a:off x="3200400" y="6057900"/>
+            <a:ext cx="2286000" cy="237744"/>
+          </a:xfrm>
+          <a:prstGeom prst="rect">
+            <a:avLst/>
+          </a:prstGeom>
+          <a:noFill/>
+        </p:spPr>
+        <p:txBody>
+          <a:bodyPr wrap="square">
+            <a:spAutoFit/>
+          </a:bodyPr>
+          <a:lstStyle/>
+          <a:p>
+            <a:pPr algn="ctr">
+              <a:defRPr sz="900" b="0">
+                <a:solidFill>
+                  <a:srgbClr val="FFFFFF"/>
+                </a:solidFill>
+                <a:latin typeface="Arial"/>
+              </a:defRPr>
+            </a:pPr>
+            <a:r>
+              <a:t>180 GB VRAM</a:t>
+            </a:r>
+          </a:p>
+        </p:txBody>
+      </p:sp>
+      <p:sp>
+        <p:nvSpPr>
+          <p:cNvPr id="71" name="TextBox 70"/>
+          <p:cNvSpPr txBox="1"/>
+          <p:nvPr/>
+        </p:nvSpPr>
+        <p:spPr>
+          <a:xfrm>
+            <a:off x="5577840" y="5852159"/>
+            <a:ext cx="365760" cy="365760"/>
+          </a:xfrm>
+          <a:prstGeom prst="rect">
+            <a:avLst/>
+          </a:prstGeom>
+          <a:noFill/>
+        </p:spPr>
+        <p:txBody>
+          <a:bodyPr wrap="square">
+            <a:spAutoFit/>
+          </a:bodyPr>
+          <a:lstStyle/>
+          <a:p>
+            <a:pPr algn="ctr">
+              <a:defRPr sz="2200" b="0">
+                <a:solidFill>
+                  <a:srgbClr val="607DB8"/>
+                </a:solidFill>
+                <a:latin typeface="Arial"/>
+              </a:defRPr>
+            </a:pPr>
+            <a:r>
+              <a:t>→</a:t>
+            </a:r>
+          </a:p>
+        </p:txBody>
+      </p:sp>
+      <p:sp>
+        <p:nvSpPr>
+          <p:cNvPr id="72" name="Rounded Rectangle 71"/>
+          <p:cNvSpPr/>
+          <p:nvPr/>
+        </p:nvSpPr>
+        <p:spPr>
+          <a:xfrm>
+            <a:off x="5943600" y="5760720"/>
+            <a:ext cx="1828800" cy="594360"/>
+          </a:xfrm>
+          <a:prstGeom prst="roundRect">
+            <a:avLst>
+              <a:gd name="adj" fmla="val 10000"/>
+            </a:avLst>
+          </a:prstGeom>
+          <a:solidFill>
+            <a:srgbClr val="474E68"/>
+          </a:solidFill>
+          <a:ln>
+            <a:noFill/>
+          </a:ln>
+        </p:spPr>
+        <p:style>
+          <a:lnRef idx="1">
+            <a:schemeClr val="accent1"/>
+          </a:lnRef>
+          <a:fillRef idx="3">
+            <a:schemeClr val="accent1"/>
+          </a:fillRef>
+          <a:effectRef idx="2">
+            <a:schemeClr val="accent1"/>
+          </a:effectRef>
+          <a:fontRef idx="minor">
+            <a:schemeClr val="lt1"/>
+          </a:fontRef>
+        </p:style>
+        <p:txBody>
+          <a:bodyPr rtlCol="0" anchor="ctr"/>
+          <a:lstStyle/>
+          <a:p>
+            <a:pPr algn="ctr"/>
+          </a:p>
+        </p:txBody>
+      </p:sp>
+      <p:sp>
+        <p:nvSpPr>
+          <p:cNvPr id="73" name="TextBox 72"/>
+          <p:cNvSpPr txBox="1"/>
+          <p:nvPr/>
+        </p:nvSpPr>
+        <p:spPr>
+          <a:xfrm>
+            <a:off x="5943600" y="5849874"/>
+            <a:ext cx="1828800" cy="267462"/>
+          </a:xfrm>
+          <a:prstGeom prst="rect">
+            <a:avLst/>
+          </a:prstGeom>
+          <a:noFill/>
+        </p:spPr>
+        <p:txBody>
+          <a:bodyPr wrap="square">
+            <a:spAutoFit/>
+          </a:bodyPr>
+          <a:lstStyle/>
+          <a:p>
+            <a:pPr algn="ctr">
+              <a:defRPr sz="1200" b="1">
+                <a:solidFill>
+                  <a:srgbClr val="FFFFFF"/>
+                </a:solidFill>
+                <a:latin typeface="Arial"/>
+              </a:defRPr>
+            </a:pPr>
+            <a:r>
+              <a:t>Northflank</a:t>
+            </a:r>
+          </a:p>
+        </p:txBody>
+      </p:sp>
+      <p:sp>
+        <p:nvSpPr>
+          <p:cNvPr id="74" name="TextBox 73"/>
+          <p:cNvSpPr txBox="1"/>
+          <p:nvPr/>
+        </p:nvSpPr>
+        <p:spPr>
+          <a:xfrm>
+            <a:off x="5943600" y="6057900"/>
+            <a:ext cx="1828800" cy="237744"/>
+          </a:xfrm>
+          <a:prstGeom prst="rect">
+            <a:avLst/>
+          </a:prstGeom>
+          <a:noFill/>
+        </p:spPr>
+        <p:txBody>
+          <a:bodyPr wrap="square">
+            <a:spAutoFit/>
+          </a:bodyPr>
+          <a:lstStyle/>
+          <a:p>
+            <a:pPr algn="ctr">
+              <a:defRPr sz="900" b="0">
+                <a:solidFill>
+                  <a:srgbClr val="FFFFFF"/>
+                </a:solidFill>
+                <a:latin typeface="Arial"/>
+              </a:defRPr>
+            </a:pPr>
+            <a:r>
+              <a:t>Container service</a:t>
+            </a:r>
+          </a:p>
+        </p:txBody>
+      </p:sp>
+      <p:sp>
+        <p:nvSpPr>
+          <p:cNvPr id="75" name="TextBox 74"/>
+          <p:cNvSpPr txBox="1"/>
+          <p:nvPr/>
+        </p:nvSpPr>
+        <p:spPr>
+          <a:xfrm>
+            <a:off x="7863840" y="5852159"/>
+            <a:ext cx="365760" cy="365760"/>
+          </a:xfrm>
+          <a:prstGeom prst="rect">
+            <a:avLst/>
+          </a:prstGeom>
+          <a:noFill/>
+        </p:spPr>
+        <p:txBody>
+          <a:bodyPr wrap="square">
+            <a:spAutoFit/>
+          </a:bodyPr>
+          <a:lstStyle/>
+          <a:p>
+            <a:pPr algn="ctr">
+              <a:defRPr sz="2200" b="0">
+                <a:solidFill>
+                  <a:srgbClr val="607DB8"/>
+                </a:solidFill>
+                <a:latin typeface="Arial"/>
+              </a:defRPr>
+            </a:pPr>
+            <a:r>
+              <a:t>→</a:t>
+            </a:r>
+          </a:p>
+        </p:txBody>
+      </p:sp>
+      <p:sp>
+        <p:nvSpPr>
+          <p:cNvPr id="76" name="Rounded Rectangle 75"/>
+          <p:cNvSpPr/>
+          <p:nvPr/>
+        </p:nvSpPr>
+        <p:spPr>
+          <a:xfrm>
+            <a:off x="8229600" y="5760720"/>
+            <a:ext cx="1828800" cy="594360"/>
+          </a:xfrm>
+          <a:prstGeom prst="roundRect">
+            <a:avLst>
+              <a:gd name="adj" fmla="val 10000"/>
+            </a:avLst>
+          </a:prstGeom>
+          <a:solidFill>
+            <a:srgbClr val="474E68"/>
+          </a:solidFill>
+          <a:ln>
+            <a:noFill/>
+          </a:ln>
+        </p:spPr>
+        <p:style>
+          <a:lnRef idx="1">
+            <a:schemeClr val="accent1"/>
+          </a:lnRef>
+          <a:fillRef idx="3">
+            <a:schemeClr val="accent1"/>
+          </a:fillRef>
+          <a:effectRef idx="2">
+            <a:schemeClr val="accent1"/>
+          </a:effectRef>
+          <a:fontRef idx="minor">
+            <a:schemeClr val="lt1"/>
+          </a:fontRef>
+        </p:style>
+        <p:txBody>
+          <a:bodyPr rtlCol="0" anchor="ctr"/>
+          <a:lstStyle/>
+          <a:p>
+            <a:pPr algn="ctr"/>
+          </a:p>
+        </p:txBody>
+      </p:sp>
+      <p:sp>
+        <p:nvSpPr>
+          <p:cNvPr id="77" name="TextBox 76"/>
+          <p:cNvSpPr txBox="1"/>
+          <p:nvPr/>
+        </p:nvSpPr>
+        <p:spPr>
+          <a:xfrm>
+            <a:off x="8229600" y="5849874"/>
+            <a:ext cx="1828800" cy="267462"/>
+          </a:xfrm>
+          <a:prstGeom prst="rect">
+            <a:avLst/>
+          </a:prstGeom>
+          <a:noFill/>
+        </p:spPr>
+        <p:txBody>
+          <a:bodyPr wrap="square">
+            <a:spAutoFit/>
+          </a:bodyPr>
+          <a:lstStyle/>
+          <a:p>
+            <a:pPr algn="ctr">
+              <a:defRPr sz="1200" b="1">
+                <a:solidFill>
+                  <a:srgbClr val="FFFFFF"/>
+                </a:solidFill>
+                <a:latin typeface="Arial"/>
+              </a:defRPr>
+            </a:pPr>
+            <a:r>
+              <a:t>FastAPI</a:t>
+            </a:r>
+          </a:p>
+        </p:txBody>
+      </p:sp>
+      <p:sp>
+        <p:nvSpPr>
+          <p:cNvPr id="78" name="TextBox 77"/>
+          <p:cNvSpPr txBox="1"/>
+          <p:nvPr/>
+        </p:nvSpPr>
+        <p:spPr>
+          <a:xfrm>
+            <a:off x="8229600" y="6057900"/>
+            <a:ext cx="1828800" cy="237744"/>
+          </a:xfrm>
+          <a:prstGeom prst="rect">
+            <a:avLst/>
+          </a:prstGeom>
+          <a:noFill/>
+        </p:spPr>
+        <p:txBody>
+          <a:bodyPr wrap="square">
+            <a:spAutoFit/>
+          </a:bodyPr>
+          <a:lstStyle/>
+          <a:p>
+            <a:pPr algn="ctr">
+              <a:defRPr sz="900" b="0">
+                <a:solidFill>
+                  <a:srgbClr val="FFFFFF"/>
+                </a:solidFill>
+                <a:latin typeface="Arial"/>
+              </a:defRPr>
+            </a:pPr>
+            <a:r>
+              <a:t>/predict endpoint</a:t>
+            </a:r>
+          </a:p>
+        </p:txBody>
+      </p:sp>
+      <p:sp>
+        <p:nvSpPr>
+          <p:cNvPr id="79" name="TextBox 78"/>
+          <p:cNvSpPr txBox="1"/>
+          <p:nvPr/>
+        </p:nvSpPr>
+        <p:spPr>
+          <a:xfrm>
+            <a:off x="10332720" y="5715000"/>
+            <a:ext cx="1645920" cy="320040"/>
+          </a:xfrm>
+          <a:prstGeom prst="rect">
+            <a:avLst/>
+          </a:prstGeom>
+          <a:noFill/>
+        </p:spPr>
+        <p:txBody>
+          <a:bodyPr wrap="square">
+            <a:spAutoFit/>
+          </a:bodyPr>
+          <a:lstStyle/>
+          <a:p>
+            <a:pPr algn="ctr">
+              <a:defRPr sz="900" b="1">
+                <a:solidFill>
+                  <a:srgbClr val="93AED2"/>
+                </a:solidFill>
+                <a:latin typeface="Arial"/>
+              </a:defRPr>
+            </a:pPr>
+            <a:r>
+              <a:t>LEARNING LOOP</a:t>
+            </a:r>
+          </a:p>
+        </p:txBody>
+      </p:sp>
+      <p:sp>
+        <p:nvSpPr>
+          <p:cNvPr id="80" name="Rounded Rectangle 79"/>
+          <p:cNvSpPr/>
+          <p:nvPr/>
+        </p:nvSpPr>
+        <p:spPr>
+          <a:xfrm>
+            <a:off x="10332720" y="5989320"/>
+            <a:ext cx="1463040" cy="365760"/>
+          </a:xfrm>
+          <a:prstGeom prst="roundRect">
+            <a:avLst>
+              <a:gd name="adj" fmla="val 12000"/>
             </a:avLst>
           </a:prstGeom>
           <a:solidFill>
@@ -5017,71 +7372,28 @@
       </p:sp>
       <p:sp>
         <p:nvSpPr>
-          <p:cNvPr id="20" name="Oval 19"/>
-          <p:cNvSpPr/>
-          <p:nvPr/>
-        </p:nvSpPr>
-        <p:spPr>
-          <a:xfrm>
-            <a:off x="2834639" y="4590288"/>
-            <a:ext cx="164592" cy="164592"/>
-          </a:xfrm>
-          <a:prstGeom prst="ellipse">
-            <a:avLst/>
-          </a:prstGeom>
-          <a:solidFill>
-            <a:srgbClr val="3B82F6"/>
-          </a:solidFill>
-          <a:ln>
-            <a:noFill/>
-          </a:ln>
-        </p:spPr>
-        <p:style>
-          <a:lnRef idx="1">
-            <a:schemeClr val="accent1"/>
-          </a:lnRef>
-          <a:fillRef idx="3">
-            <a:schemeClr val="accent1"/>
-          </a:fillRef>
-          <a:effectRef idx="2">
-            <a:schemeClr val="accent1"/>
-          </a:effectRef>
-          <a:fontRef idx="minor">
-            <a:schemeClr val="lt1"/>
-          </a:fontRef>
-        </p:style>
-        <p:txBody>
-          <a:bodyPr rtlCol="0" anchor="ctr"/>
-          <a:lstStyle/>
-          <a:p>
-            <a:pPr algn="ctr"/>
-          </a:p>
-        </p:txBody>
-      </p:sp>
-      <p:sp>
-        <p:nvSpPr>
-          <p:cNvPr id="21" name="TextBox 20"/>
-          <p:cNvSpPr txBox="1"/>
-          <p:nvPr/>
-        </p:nvSpPr>
-        <p:spPr>
-          <a:xfrm>
-            <a:off x="3063239" y="4480559"/>
-            <a:ext cx="1371600" cy="457200"/>
-          </a:xfrm>
-          <a:prstGeom prst="rect">
-            <a:avLst/>
-          </a:prstGeom>
-          <a:noFill/>
-        </p:spPr>
-        <p:txBody>
-          <a:bodyPr wrap="square">
-            <a:spAutoFit/>
-          </a:bodyPr>
-          <a:lstStyle/>
-          <a:p>
-            <a:pPr algn="l">
-              <a:defRPr sz="1400" b="1">
+          <p:cNvPr id="81" name="TextBox 80"/>
+          <p:cNvSpPr txBox="1"/>
+          <p:nvPr/>
+        </p:nvSpPr>
+        <p:spPr>
+          <a:xfrm>
+            <a:off x="10332720" y="6044183"/>
+            <a:ext cx="1463040" cy="256031"/>
+          </a:xfrm>
+          <a:prstGeom prst="rect">
+            <a:avLst/>
+          </a:prstGeom>
+          <a:noFill/>
+        </p:spPr>
+        <p:txBody>
+          <a:bodyPr wrap="square">
+            <a:spAutoFit/>
+          </a:bodyPr>
+          <a:lstStyle/>
+          <a:p>
+            <a:pPr algn="ctr">
+              <a:defRPr sz="1000" b="1">
                 <a:solidFill>
                   <a:srgbClr val="FFFFFF"/>
                 </a:solidFill>
@@ -5089,403 +7401,7 @@
               </a:defRPr>
             </a:pPr>
             <a:r>
-              <a:t>Human teaches</a:t>
-            </a:r>
-          </a:p>
-        </p:txBody>
-      </p:sp>
-      <p:sp>
-        <p:nvSpPr>
-          <p:cNvPr id="22" name="TextBox 21"/>
-          <p:cNvSpPr txBox="1"/>
-          <p:nvPr/>
-        </p:nvSpPr>
-        <p:spPr>
-          <a:xfrm>
-            <a:off x="4754879" y="4389120"/>
-            <a:ext cx="365760" cy="640080"/>
-          </a:xfrm>
-          <a:prstGeom prst="rect">
-            <a:avLst/>
-          </a:prstGeom>
-          <a:noFill/>
-        </p:spPr>
-        <p:txBody>
-          <a:bodyPr wrap="square">
-            <a:spAutoFit/>
-          </a:bodyPr>
-          <a:lstStyle/>
-          <a:p>
-            <a:pPr algn="ctr">
-              <a:defRPr sz="2400" b="1">
-                <a:solidFill>
-                  <a:srgbClr val="607DB8"/>
-                </a:solidFill>
-                <a:latin typeface="Arial"/>
-              </a:defRPr>
-            </a:pPr>
-            <a:r>
-              <a:t>+</a:t>
-            </a:r>
-          </a:p>
-        </p:txBody>
-      </p:sp>
-      <p:sp>
-        <p:nvSpPr>
-          <p:cNvPr id="23" name="Rounded Rectangle 22"/>
-          <p:cNvSpPr/>
-          <p:nvPr/>
-        </p:nvSpPr>
-        <p:spPr>
-          <a:xfrm>
-            <a:off x="5212079" y="4389120"/>
-            <a:ext cx="2011680" cy="640080"/>
-          </a:xfrm>
-          <a:prstGeom prst="roundRect">
-            <a:avLst>
-              <a:gd name="adj" fmla="val 15000"/>
-            </a:avLst>
-          </a:prstGeom>
-          <a:solidFill>
-            <a:srgbClr val="1B336B"/>
-          </a:solidFill>
-          <a:ln w="25400">
-            <a:solidFill>
-              <a:srgbClr val="A78BFA"/>
-            </a:solidFill>
-          </a:ln>
-        </p:spPr>
-        <p:style>
-          <a:lnRef idx="1">
-            <a:schemeClr val="accent1"/>
-          </a:lnRef>
-          <a:fillRef idx="3">
-            <a:schemeClr val="accent1"/>
-          </a:fillRef>
-          <a:effectRef idx="2">
-            <a:schemeClr val="accent1"/>
-          </a:effectRef>
-          <a:fontRef idx="minor">
-            <a:schemeClr val="lt1"/>
-          </a:fontRef>
-        </p:style>
-        <p:txBody>
-          <a:bodyPr rtlCol="0" anchor="ctr"/>
-          <a:lstStyle/>
-          <a:p>
-            <a:pPr algn="ctr"/>
-          </a:p>
-        </p:txBody>
-      </p:sp>
-      <p:sp>
-        <p:nvSpPr>
-          <p:cNvPr id="24" name="Oval 23"/>
-          <p:cNvSpPr/>
-          <p:nvPr/>
-        </p:nvSpPr>
-        <p:spPr>
-          <a:xfrm>
-            <a:off x="5486399" y="4590288"/>
-            <a:ext cx="164592" cy="164592"/>
-          </a:xfrm>
-          <a:prstGeom prst="ellipse">
-            <a:avLst/>
-          </a:prstGeom>
-          <a:solidFill>
-            <a:srgbClr val="A78BFA"/>
-          </a:solidFill>
-          <a:ln>
-            <a:noFill/>
-          </a:ln>
-        </p:spPr>
-        <p:style>
-          <a:lnRef idx="1">
-            <a:schemeClr val="accent1"/>
-          </a:lnRef>
-          <a:fillRef idx="3">
-            <a:schemeClr val="accent1"/>
-          </a:fillRef>
-          <a:effectRef idx="2">
-            <a:schemeClr val="accent1"/>
-          </a:effectRef>
-          <a:fontRef idx="minor">
-            <a:schemeClr val="lt1"/>
-          </a:fontRef>
-        </p:style>
-        <p:txBody>
-          <a:bodyPr rtlCol="0" anchor="ctr"/>
-          <a:lstStyle/>
-          <a:p>
-            <a:pPr algn="ctr"/>
-          </a:p>
-        </p:txBody>
-      </p:sp>
-      <p:sp>
-        <p:nvSpPr>
-          <p:cNvPr id="25" name="TextBox 24"/>
-          <p:cNvSpPr txBox="1"/>
-          <p:nvPr/>
-        </p:nvSpPr>
-        <p:spPr>
-          <a:xfrm>
-            <a:off x="5714999" y="4480559"/>
-            <a:ext cx="1371600" cy="457200"/>
-          </a:xfrm>
-          <a:prstGeom prst="rect">
-            <a:avLst/>
-          </a:prstGeom>
-          <a:noFill/>
-        </p:spPr>
-        <p:txBody>
-          <a:bodyPr wrap="square">
-            <a:spAutoFit/>
-          </a:bodyPr>
-          <a:lstStyle/>
-          <a:p>
-            <a:pPr algn="l">
-              <a:defRPr sz="1400" b="1">
-                <a:solidFill>
-                  <a:srgbClr val="FFFFFF"/>
-                </a:solidFill>
-                <a:latin typeface="Arial"/>
-              </a:defRPr>
-            </a:pPr>
-            <a:r>
-              <a:t>AI learns</a:t>
-            </a:r>
-          </a:p>
-        </p:txBody>
-      </p:sp>
-      <p:sp>
-        <p:nvSpPr>
-          <p:cNvPr id="26" name="TextBox 25"/>
-          <p:cNvSpPr txBox="1"/>
-          <p:nvPr/>
-        </p:nvSpPr>
-        <p:spPr>
-          <a:xfrm>
-            <a:off x="7406640" y="4389120"/>
-            <a:ext cx="365760" cy="640080"/>
-          </a:xfrm>
-          <a:prstGeom prst="rect">
-            <a:avLst/>
-          </a:prstGeom>
-          <a:noFill/>
-        </p:spPr>
-        <p:txBody>
-          <a:bodyPr wrap="square">
-            <a:spAutoFit/>
-          </a:bodyPr>
-          <a:lstStyle/>
-          <a:p>
-            <a:pPr algn="ctr">
-              <a:defRPr sz="2400" b="1">
-                <a:solidFill>
-                  <a:srgbClr val="607DB8"/>
-                </a:solidFill>
-                <a:latin typeface="Arial"/>
-              </a:defRPr>
-            </a:pPr>
-            <a:r>
-              <a:t>=</a:t>
-            </a:r>
-          </a:p>
-        </p:txBody>
-      </p:sp>
-      <p:sp>
-        <p:nvSpPr>
-          <p:cNvPr id="27" name="Rounded Rectangle 26"/>
-          <p:cNvSpPr/>
-          <p:nvPr/>
-        </p:nvSpPr>
-        <p:spPr>
-          <a:xfrm>
-            <a:off x="7863840" y="4389120"/>
-            <a:ext cx="2011680" cy="640080"/>
-          </a:xfrm>
-          <a:prstGeom prst="roundRect">
-            <a:avLst>
-              <a:gd name="adj" fmla="val 15000"/>
-            </a:avLst>
-          </a:prstGeom>
-          <a:solidFill>
-            <a:srgbClr val="1B336B"/>
-          </a:solidFill>
-          <a:ln w="25400">
-            <a:solidFill>
-              <a:srgbClr val="10B981"/>
-            </a:solidFill>
-          </a:ln>
-        </p:spPr>
-        <p:style>
-          <a:lnRef idx="1">
-            <a:schemeClr val="accent1"/>
-          </a:lnRef>
-          <a:fillRef idx="3">
-            <a:schemeClr val="accent1"/>
-          </a:fillRef>
-          <a:effectRef idx="2">
-            <a:schemeClr val="accent1"/>
-          </a:effectRef>
-          <a:fontRef idx="minor">
-            <a:schemeClr val="lt1"/>
-          </a:fontRef>
-        </p:style>
-        <p:txBody>
-          <a:bodyPr rtlCol="0" anchor="ctr"/>
-          <a:lstStyle/>
-          <a:p>
-            <a:pPr algn="ctr"/>
-          </a:p>
-        </p:txBody>
-      </p:sp>
-      <p:sp>
-        <p:nvSpPr>
-          <p:cNvPr id="28" name="Oval 27"/>
-          <p:cNvSpPr/>
-          <p:nvPr/>
-        </p:nvSpPr>
-        <p:spPr>
-          <a:xfrm>
-            <a:off x="8138160" y="4590288"/>
-            <a:ext cx="164592" cy="164592"/>
-          </a:xfrm>
-          <a:prstGeom prst="ellipse">
-            <a:avLst/>
-          </a:prstGeom>
-          <a:solidFill>
-            <a:srgbClr val="10B981"/>
-          </a:solidFill>
-          <a:ln>
-            <a:noFill/>
-          </a:ln>
-        </p:spPr>
-        <p:style>
-          <a:lnRef idx="1">
-            <a:schemeClr val="accent1"/>
-          </a:lnRef>
-          <a:fillRef idx="3">
-            <a:schemeClr val="accent1"/>
-          </a:fillRef>
-          <a:effectRef idx="2">
-            <a:schemeClr val="accent1"/>
-          </a:effectRef>
-          <a:fontRef idx="minor">
-            <a:schemeClr val="lt1"/>
-          </a:fontRef>
-        </p:style>
-        <p:txBody>
-          <a:bodyPr rtlCol="0" anchor="ctr"/>
-          <a:lstStyle/>
-          <a:p>
-            <a:pPr algn="ctr"/>
-          </a:p>
-        </p:txBody>
-      </p:sp>
-      <p:sp>
-        <p:nvSpPr>
-          <p:cNvPr id="29" name="TextBox 28"/>
-          <p:cNvSpPr txBox="1"/>
-          <p:nvPr/>
-        </p:nvSpPr>
-        <p:spPr>
-          <a:xfrm>
-            <a:off x="8366760" y="4480559"/>
-            <a:ext cx="1371600" cy="457200"/>
-          </a:xfrm>
-          <a:prstGeom prst="rect">
-            <a:avLst/>
-          </a:prstGeom>
-          <a:noFill/>
-        </p:spPr>
-        <p:txBody>
-          <a:bodyPr wrap="square">
-            <a:spAutoFit/>
-          </a:bodyPr>
-          <a:lstStyle/>
-          <a:p>
-            <a:pPr algn="l">
-              <a:defRPr sz="1400" b="1">
-                <a:solidFill>
-                  <a:srgbClr val="FFFFFF"/>
-                </a:solidFill>
-                <a:latin typeface="Arial"/>
-              </a:defRPr>
-            </a:pPr>
-            <a:r>
-              <a:t>Compound loop</a:t>
-            </a:r>
-          </a:p>
-        </p:txBody>
-      </p:sp>
-      <p:sp>
-        <p:nvSpPr>
-          <p:cNvPr id="30" name="TextBox 29"/>
-          <p:cNvSpPr txBox="1"/>
-          <p:nvPr/>
-        </p:nvSpPr>
-        <p:spPr>
-          <a:xfrm>
-            <a:off x="0" y="5669280"/>
-            <a:ext cx="12191695" cy="457200"/>
-          </a:xfrm>
-          <a:prstGeom prst="rect">
-            <a:avLst/>
-          </a:prstGeom>
-          <a:noFill/>
-        </p:spPr>
-        <p:txBody>
-          <a:bodyPr wrap="square">
-            <a:spAutoFit/>
-          </a:bodyPr>
-          <a:lstStyle/>
-          <a:p>
-            <a:pPr algn="ctr">
-              <a:defRPr sz="1300" b="0">
-                <a:solidFill>
-                  <a:srgbClr val="607DB8"/>
-                </a:solidFill>
-                <a:latin typeface="Arial"/>
-              </a:defRPr>
-            </a:pPr>
-            <a:r>
-              <a:t>Meta TRIBE v2   ·   Anthropic Claude   ·   NVIDIA B200   ·   Convex   ·   Clay</a:t>
-            </a:r>
-          </a:p>
-        </p:txBody>
-      </p:sp>
-      <p:sp>
-        <p:nvSpPr>
-          <p:cNvPr id="31" name="TextBox 30"/>
-          <p:cNvSpPr txBox="1"/>
-          <p:nvPr/>
-        </p:nvSpPr>
-        <p:spPr>
-          <a:xfrm>
-            <a:off x="0" y="6126480"/>
-            <a:ext cx="12191695" cy="365760"/>
-          </a:xfrm>
-          <a:prstGeom prst="rect">
-            <a:avLst/>
-          </a:prstGeom>
-          <a:noFill/>
-        </p:spPr>
-        <p:txBody>
-          <a:bodyPr wrap="square">
-            <a:spAutoFit/>
-          </a:bodyPr>
-          <a:lstStyle/>
-          <a:p>
-            <a:pPr algn="ctr">
-              <a:defRPr sz="1000" b="0">
-                <a:solidFill>
-                  <a:srgbClr val="4A5E85"/>
-                </a:solidFill>
-                <a:latin typeface="Arial"/>
-              </a:defRPr>
-            </a:pPr>
-            <a:r>
-              <a:t>Sources: Instantly 2026 · Smartlead · Backlinko 12M emails · Woodpecker 20M emails</a:t>
+              <a:t>Human ↔ AI</a:t>
             </a:r>
           </a:p>
         </p:txBody>

</xml_diff>